<commit_message>
docs: modernize Shill_Investor_Overview.pptx and Shill_Business_Plan.docx with eye-candy charts, 16:9 widescreen layout, and monetization roadmap
</commit_message>
<xml_diff>
--- a/docs/Shill_Investor_Overview.pptx
+++ b/docs/Shill_Investor_Overview.pptx
@@ -3090,14 +3090,6 @@
 <file path=ppt/slides/slide1.xml><?xml version="1.0" encoding="utf-8"?>
 <p:sld xmlns:a="http://schemas.openxmlformats.org/drawingml/2006/main" xmlns:p="http://schemas.openxmlformats.org/presentationml/2006/main" xmlns:r="http://schemas.openxmlformats.org/officeDocument/2006/relationships">
   <p:cSld>
-    <p:bg>
-      <p:bgPr>
-        <a:solidFill>
-          <a:srgbClr val="1B2A4A"/>
-        </a:solidFill>
-        <a:effectLst/>
-      </p:bgPr>
-    </p:bg>
     <p:spTree>
       <p:nvGrpSpPr>
         <p:cNvPr id="1" name=""/>
@@ -3107,14 +3099,57 @@
       <p:grpSpPr/>
       <p:sp>
         <p:nvSpPr>
-          <p:cNvPr id="2" name="TextBox 1"/>
+          <p:cNvPr id="2" name="Rectangle 1"/>
+          <p:cNvSpPr/>
+          <p:nvPr/>
+        </p:nvSpPr>
+        <p:spPr>
+          <a:xfrm>
+            <a:off x="0" y="0"/>
+            <a:ext cx="12191695" cy="6858000"/>
+          </a:xfrm>
+          <a:prstGeom prst="rect">
+            <a:avLst/>
+          </a:prstGeom>
+          <a:solidFill>
+            <a:srgbClr val="0F172A"/>
+          </a:solidFill>
+          <a:ln>
+            <a:noFill/>
+          </a:ln>
+        </p:spPr>
+        <p:style>
+          <a:lnRef idx="1">
+            <a:schemeClr val="accent1"/>
+          </a:lnRef>
+          <a:fillRef idx="3">
+            <a:schemeClr val="accent1"/>
+          </a:fillRef>
+          <a:effectRef idx="2">
+            <a:schemeClr val="accent1"/>
+          </a:effectRef>
+          <a:fontRef idx="minor">
+            <a:schemeClr val="lt1"/>
+          </a:fontRef>
+        </p:style>
+        <p:txBody>
+          <a:bodyPr rtlCol="0" anchor="ctr"/>
+          <a:lstStyle/>
+          <a:p>
+            <a:pPr algn="ctr"/>
+          </a:p>
+        </p:txBody>
+      </p:sp>
+      <p:sp>
+        <p:nvSpPr>
+          <p:cNvPr id="3" name="TextBox 2"/>
           <p:cNvSpPr txBox="1"/>
           <p:nvPr/>
         </p:nvSpPr>
         <p:spPr>
           <a:xfrm>
-            <a:off x="731520" y="1280160"/>
-            <a:ext cx="10698480" cy="1828800"/>
+            <a:off x="914400" y="1645920"/>
+            <a:ext cx="10362895" cy="3657600"/>
           </a:xfrm>
           <a:prstGeom prst="rect">
             <a:avLst/>
@@ -3122,87 +3157,330 @@
           <a:noFill/>
         </p:spPr>
         <p:txBody>
-          <a:bodyPr wrap="none">
+          <a:bodyPr wrap="square">
             <a:spAutoFit/>
           </a:bodyPr>
           <a:lstStyle/>
           <a:p>
-            <a:pPr algn="ctr"/>
-            <a:r>
-              <a:rPr sz="4400" b="1">
-                <a:solidFill>
-                  <a:srgbClr val="FFFFFF"/>
-                </a:solidFill>
-              </a:rPr>
-              <a:t>SHILL</a:t>
-            </a:r>
-          </a:p>
-        </p:txBody>
-      </p:sp>
-      <p:sp>
-        <p:nvSpPr>
-          <p:cNvPr id="3" name="TextBox 2"/>
-          <p:cNvSpPr txBox="1"/>
+            <a:pPr>
+              <a:defRPr sz="1200" b="1">
+                <a:solidFill>
+                  <a:srgbClr val="34D399"/>
+                </a:solidFill>
+              </a:defRPr>
+            </a:pPr>
+            <a:r>
+              <a:t>DEMOCRATIZE AI AT ALL COSTS • PRODUCTION RELEASE v0.2.0</a:t>
+            </a:r>
+          </a:p>
+          <a:p>
+            <a:pPr>
+              <a:spcBef>
+                <a:spcPts val="1400"/>
+              </a:spcBef>
+              <a:defRPr sz="3600" b="1">
+                <a:solidFill>
+                  <a:srgbClr val="F8FAFC"/>
+                </a:solidFill>
+              </a:defRPr>
+            </a:pPr>
+            <a:r>
+              <a:t>SHILL: Sovereign Autonomous Bot Mesh</a:t>
+            </a:r>
+            <a:br/>
+            <a:r>
+              <a:t>&amp; Decentralized Knowledge State</a:t>
+            </a:r>
+          </a:p>
+          <a:p>
+            <a:pPr>
+              <a:spcBef>
+                <a:spcPts val="1600"/>
+              </a:spcBef>
+              <a:defRPr sz="1500">
+                <a:solidFill>
+                  <a:srgbClr val="94A3B8"/>
+                </a:solidFill>
+              </a:defRPr>
+            </a:pPr>
+            <a:r>
+              <a:t>A zero-touch, peer-to-peer adversarial dialectic swarm that cross-examines hypotheses, weeds out corporate bias and hallucinations, executes local neural inference, and synthesizes golden fine-tuning datasets.</a:t>
+            </a:r>
+          </a:p>
+        </p:txBody>
+      </p:sp>
+      <p:sp>
+        <p:nvSpPr>
+          <p:cNvPr id="4" name="Rounded Rectangle 3"/>
+          <p:cNvSpPr/>
           <p:nvPr/>
         </p:nvSpPr>
         <p:spPr>
           <a:xfrm>
-            <a:off x="1371600" y="3291840"/>
-            <a:ext cx="9418320" cy="1097280"/>
-          </a:xfrm>
-          <a:prstGeom prst="rect">
+            <a:off x="914400" y="4937760"/>
+            <a:ext cx="2377440" cy="1188720"/>
+          </a:xfrm>
+          <a:prstGeom prst="roundRect">
             <a:avLst/>
           </a:prstGeom>
-          <a:noFill/>
-        </p:spPr>
-        <p:txBody>
-          <a:bodyPr wrap="none">
-            <a:spAutoFit/>
-          </a:bodyPr>
-          <a:lstStyle/>
-          <a:p>
-            <a:pPr algn="ctr"/>
-            <a:r>
-              <a:rPr sz="2200" b="0">
-                <a:solidFill>
-                  <a:srgbClr val="C7D5E0"/>
-                </a:solidFill>
-              </a:rPr>
-              <a:t>Trustworthy AI, debated in the open — owned by everyone.</a:t>
-            </a:r>
-          </a:p>
-        </p:txBody>
-      </p:sp>
-      <p:sp>
-        <p:nvSpPr>
-          <p:cNvPr id="4" name="TextBox 3"/>
-          <p:cNvSpPr txBox="1"/>
+          <a:solidFill>
+            <a:srgbClr val="172132"/>
+          </a:solidFill>
+          <a:ln w="12700">
+            <a:solidFill>
+              <a:srgbClr val="334155"/>
+            </a:solidFill>
+          </a:ln>
+        </p:spPr>
+        <p:style>
+          <a:lnRef idx="1">
+            <a:schemeClr val="accent1"/>
+          </a:lnRef>
+          <a:fillRef idx="3">
+            <a:schemeClr val="accent1"/>
+          </a:fillRef>
+          <a:effectRef idx="2">
+            <a:schemeClr val="accent1"/>
+          </a:effectRef>
+          <a:fontRef idx="minor">
+            <a:schemeClr val="lt1"/>
+          </a:fontRef>
+        </p:style>
+        <p:txBody>
+          <a:bodyPr rtlCol="0" anchor="ctr" wrap="square" lIns="228600" rIns="228600" tIns="201168" bIns="201168"/>
+          <a:lstStyle/>
+          <a:p>
+            <a:pPr algn="ctr">
+              <a:defRPr sz="1400" b="1">
+                <a:solidFill>
+                  <a:srgbClr val="38BDF8"/>
+                </a:solidFill>
+              </a:defRPr>
+            </a:pPr>
+            <a:r>
+              <a:t>⚡ Live Inference</a:t>
+            </a:r>
+          </a:p>
+          <a:p>
+            <a:pPr>
+              <a:spcBef>
+                <a:spcPts val="800"/>
+              </a:spcBef>
+              <a:defRPr sz="1100">
+                <a:solidFill>
+                  <a:srgbClr val="94A3B8"/>
+                </a:solidFill>
+              </a:defRPr>
+            </a:pPr>
+            <a:r>
+              <a:t>Real local Ollama (Llama 3.1 8B), vLLM, LM Studio, &amp; Jan integration.</a:t>
+            </a:r>
+          </a:p>
+        </p:txBody>
+      </p:sp>
+      <p:sp>
+        <p:nvSpPr>
+          <p:cNvPr id="5" name="Rounded Rectangle 4"/>
+          <p:cNvSpPr/>
           <p:nvPr/>
         </p:nvSpPr>
         <p:spPr>
           <a:xfrm>
-            <a:off x="1371600" y="5120640"/>
-            <a:ext cx="9418320" cy="731520"/>
-          </a:xfrm>
-          <a:prstGeom prst="rect">
+            <a:off x="3474720" y="4937760"/>
+            <a:ext cx="2377440" cy="1188720"/>
+          </a:xfrm>
+          <a:prstGeom prst="roundRect">
             <a:avLst/>
           </a:prstGeom>
-          <a:noFill/>
-        </p:spPr>
-        <p:txBody>
-          <a:bodyPr wrap="none">
-            <a:spAutoFit/>
-          </a:bodyPr>
-          <a:lstStyle/>
-          <a:p>
-            <a:pPr algn="ctr"/>
-            <a:r>
-              <a:rPr sz="1500" b="0">
-                <a:solidFill>
-                  <a:srgbClr val="96AAB9"/>
-                </a:solidFill>
-              </a:rPr>
-              <a:t>Non-technical overview • Working product, live today</a:t>
+          <a:solidFill>
+            <a:srgbClr val="172132"/>
+          </a:solidFill>
+          <a:ln w="12700">
+            <a:solidFill>
+              <a:srgbClr val="334155"/>
+            </a:solidFill>
+          </a:ln>
+        </p:spPr>
+        <p:style>
+          <a:lnRef idx="1">
+            <a:schemeClr val="accent1"/>
+          </a:lnRef>
+          <a:fillRef idx="3">
+            <a:schemeClr val="accent1"/>
+          </a:fillRef>
+          <a:effectRef idx="2">
+            <a:schemeClr val="accent1"/>
+          </a:effectRef>
+          <a:fontRef idx="minor">
+            <a:schemeClr val="lt1"/>
+          </a:fontRef>
+        </p:style>
+        <p:txBody>
+          <a:bodyPr rtlCol="0" anchor="ctr" wrap="square" lIns="228600" rIns="228600" tIns="201168" bIns="201168"/>
+          <a:lstStyle/>
+          <a:p>
+            <a:pPr algn="ctr">
+              <a:defRPr sz="1400" b="1">
+                <a:solidFill>
+                  <a:srgbClr val="A855F7"/>
+                </a:solidFill>
+              </a:defRPr>
+            </a:pPr>
+            <a:r>
+              <a:t>🧬 SETI LLM Sharding</a:t>
+            </a:r>
+          </a:p>
+          <a:p>
+            <a:pPr>
+              <a:spcBef>
+                <a:spcPts val="800"/>
+              </a:spcBef>
+              <a:defRPr sz="1100">
+                <a:solidFill>
+                  <a:srgbClr val="94A3B8"/>
+                </a:solidFill>
+              </a:defRPr>
+            </a:pPr>
+            <a:r>
+              <a:t>16-slice viral model striping with &lt;64MB volunteer node footprint.</a:t>
+            </a:r>
+          </a:p>
+        </p:txBody>
+      </p:sp>
+      <p:sp>
+        <p:nvSpPr>
+          <p:cNvPr id="6" name="Rounded Rectangle 5"/>
+          <p:cNvSpPr/>
+          <p:nvPr/>
+        </p:nvSpPr>
+        <p:spPr>
+          <a:xfrm>
+            <a:off x="6035040" y="4937760"/>
+            <a:ext cx="2377440" cy="1188720"/>
+          </a:xfrm>
+          <a:prstGeom prst="roundRect">
+            <a:avLst/>
+          </a:prstGeom>
+          <a:solidFill>
+            <a:srgbClr val="172132"/>
+          </a:solidFill>
+          <a:ln w="12700">
+            <a:solidFill>
+              <a:srgbClr val="334155"/>
+            </a:solidFill>
+          </a:ln>
+        </p:spPr>
+        <p:style>
+          <a:lnRef idx="1">
+            <a:schemeClr val="accent1"/>
+          </a:lnRef>
+          <a:fillRef idx="3">
+            <a:schemeClr val="accent1"/>
+          </a:fillRef>
+          <a:effectRef idx="2">
+            <a:schemeClr val="accent1"/>
+          </a:effectRef>
+          <a:fontRef idx="minor">
+            <a:schemeClr val="lt1"/>
+          </a:fontRef>
+        </p:style>
+        <p:txBody>
+          <a:bodyPr rtlCol="0" anchor="ctr" wrap="square" lIns="228600" rIns="228600" tIns="201168" bIns="201168"/>
+          <a:lstStyle/>
+          <a:p>
+            <a:pPr algn="ctr">
+              <a:defRPr sz="1400" b="1">
+                <a:solidFill>
+                  <a:srgbClr val="34D399"/>
+                </a:solidFill>
+              </a:defRPr>
+            </a:pPr>
+            <a:r>
+              <a:t>💎 Golden Datasets</a:t>
+            </a:r>
+          </a:p>
+          <a:p>
+            <a:pPr>
+              <a:spcBef>
+                <a:spcPts val="800"/>
+              </a:spcBef>
+              <a:defRPr sz="1100">
+                <a:solidFill>
+                  <a:srgbClr val="94A3B8"/>
+                </a:solidFill>
+              </a:defRPr>
+            </a:pPr>
+            <a:r>
+              <a:t>Automatic SFT &amp; DPO dataset generation ready for Hugging Face.</a:t>
+            </a:r>
+          </a:p>
+        </p:txBody>
+      </p:sp>
+      <p:sp>
+        <p:nvSpPr>
+          <p:cNvPr id="7" name="Rounded Rectangle 6"/>
+          <p:cNvSpPr/>
+          <p:nvPr/>
+        </p:nvSpPr>
+        <p:spPr>
+          <a:xfrm>
+            <a:off x="8595360" y="4937760"/>
+            <a:ext cx="2651760" cy="1188720"/>
+          </a:xfrm>
+          <a:prstGeom prst="roundRect">
+            <a:avLst/>
+          </a:prstGeom>
+          <a:solidFill>
+            <a:srgbClr val="172132"/>
+          </a:solidFill>
+          <a:ln w="12700">
+            <a:solidFill>
+              <a:srgbClr val="334155"/>
+            </a:solidFill>
+          </a:ln>
+        </p:spPr>
+        <p:style>
+          <a:lnRef idx="1">
+            <a:schemeClr val="accent1"/>
+          </a:lnRef>
+          <a:fillRef idx="3">
+            <a:schemeClr val="accent1"/>
+          </a:fillRef>
+          <a:effectRef idx="2">
+            <a:schemeClr val="accent1"/>
+          </a:effectRef>
+          <a:fontRef idx="minor">
+            <a:schemeClr val="lt1"/>
+          </a:fontRef>
+        </p:style>
+        <p:txBody>
+          <a:bodyPr rtlCol="0" anchor="ctr" wrap="square" lIns="228600" rIns="228600" tIns="201168" bIns="201168"/>
+          <a:lstStyle/>
+          <a:p>
+            <a:pPr algn="ctr">
+              <a:defRPr sz="1400" b="1">
+                <a:solidFill>
+                  <a:srgbClr val="F59E0B"/>
+                </a:solidFill>
+              </a:defRPr>
+            </a:pPr>
+            <a:r>
+              <a:t>🛡️ Forensic Wallets</a:t>
+            </a:r>
+          </a:p>
+          <a:p>
+            <a:pPr>
+              <a:spcBef>
+                <a:spcPts val="800"/>
+              </a:spcBef>
+              <a:defRPr sz="1100">
+                <a:solidFill>
+                  <a:srgbClr val="94A3B8"/>
+                </a:solidFill>
+              </a:defRPr>
+            </a:pPr>
+            <a:r>
+              <a:t>Ed25519 TON v4r2 wallets &amp; 0x... verifiable cryptographic on-chain proofs.</a:t>
             </a:r>
           </a:p>
         </p:txBody>
@@ -3218,14 +3496,6 @@
 <file path=ppt/slides/slide10.xml><?xml version="1.0" encoding="utf-8"?>
 <p:sld xmlns:a="http://schemas.openxmlformats.org/drawingml/2006/main" xmlns:p="http://schemas.openxmlformats.org/presentationml/2006/main" xmlns:r="http://schemas.openxmlformats.org/officeDocument/2006/relationships">
   <p:cSld>
-    <p:bg>
-      <p:bgPr>
-        <a:solidFill>
-          <a:srgbClr val="1B2A4A"/>
-        </a:solidFill>
-        <a:effectLst/>
-      </p:bgPr>
-    </p:bg>
     <p:spTree>
       <p:nvGrpSpPr>
         <p:cNvPr id="1" name=""/>
@@ -3235,14 +3505,57 @@
       <p:grpSpPr/>
       <p:sp>
         <p:nvSpPr>
-          <p:cNvPr id="2" name="TextBox 1"/>
+          <p:cNvPr id="2" name="Rectangle 1"/>
+          <p:cNvSpPr/>
+          <p:nvPr/>
+        </p:nvSpPr>
+        <p:spPr>
+          <a:xfrm>
+            <a:off x="0" y="0"/>
+            <a:ext cx="12191695" cy="6858000"/>
+          </a:xfrm>
+          <a:prstGeom prst="rect">
+            <a:avLst/>
+          </a:prstGeom>
+          <a:solidFill>
+            <a:srgbClr val="0F172A"/>
+          </a:solidFill>
+          <a:ln>
+            <a:noFill/>
+          </a:ln>
+        </p:spPr>
+        <p:style>
+          <a:lnRef idx="1">
+            <a:schemeClr val="accent1"/>
+          </a:lnRef>
+          <a:fillRef idx="3">
+            <a:schemeClr val="accent1"/>
+          </a:fillRef>
+          <a:effectRef idx="2">
+            <a:schemeClr val="accent1"/>
+          </a:effectRef>
+          <a:fontRef idx="minor">
+            <a:schemeClr val="lt1"/>
+          </a:fontRef>
+        </p:style>
+        <p:txBody>
+          <a:bodyPr rtlCol="0" anchor="ctr"/>
+          <a:lstStyle/>
+          <a:p>
+            <a:pPr algn="ctr"/>
+          </a:p>
+        </p:txBody>
+      </p:sp>
+      <p:sp>
+        <p:nvSpPr>
+          <p:cNvPr id="3" name="TextBox 2"/>
           <p:cNvSpPr txBox="1"/>
           <p:nvPr/>
         </p:nvSpPr>
         <p:spPr>
           <a:xfrm>
-            <a:off x="731520" y="1828800"/>
-            <a:ext cx="10698480" cy="1828800"/>
+            <a:off x="914400" y="1371600"/>
+            <a:ext cx="10362895" cy="4114800"/>
           </a:xfrm>
           <a:prstGeom prst="rect">
             <a:avLst/>
@@ -3250,53 +3563,261 @@
           <a:noFill/>
         </p:spPr>
         <p:txBody>
-          <a:bodyPr wrap="none">
+          <a:bodyPr wrap="square">
             <a:spAutoFit/>
           </a:bodyPr>
           <a:lstStyle/>
           <a:p>
-            <a:pPr algn="ctr"/>
-            <a:r>
-              <a:rPr sz="3200" b="1">
-                <a:solidFill>
-                  <a:srgbClr val="FFFFFF"/>
-                </a:solidFill>
-              </a:rPr>
-              <a:t>Free to use. Impossible to rig. Pays its contributors.</a:t>
-            </a:r>
-          </a:p>
-        </p:txBody>
-      </p:sp>
-      <p:sp>
-        <p:nvSpPr>
-          <p:cNvPr id="3" name="TextBox 2"/>
-          <p:cNvSpPr txBox="1"/>
+            <a:pPr>
+              <a:defRPr sz="1200" b="1">
+                <a:solidFill>
+                  <a:srgbClr val="38BDF8"/>
+                </a:solidFill>
+              </a:defRPr>
+            </a:pPr>
+            <a:r>
+              <a:t>THE FUTURE OF SOVEREIGN ARTIFICIAL INTELLIGENCE</a:t>
+            </a:r>
+          </a:p>
+          <a:p>
+            <a:pPr>
+              <a:spcBef>
+                <a:spcPts val="1200"/>
+              </a:spcBef>
+              <a:defRPr sz="3800" b="1">
+                <a:solidFill>
+                  <a:srgbClr val="F8FAFC"/>
+                </a:solidFill>
+              </a:defRPr>
+            </a:pPr>
+            <a:r>
+              <a:t>Free to Use. Impossible to Rig. Built for Humanity.</a:t>
+            </a:r>
+          </a:p>
+          <a:p>
+            <a:pPr>
+              <a:spcBef>
+                <a:spcPts val="1600"/>
+              </a:spcBef>
+              <a:defRPr sz="1600">
+                <a:solidFill>
+                  <a:srgbClr val="94A3B8"/>
+                </a:solidFill>
+              </a:defRPr>
+            </a:pPr>
+            <a:r>
+              <a:t>Shill is not an unproven whitepaper or speculative concept. It is a live, working sovereign AI node with neural inference, sharded storage, verified economics, and full cross-platform support ready for GitHub public deployment.</a:t>
+            </a:r>
+          </a:p>
+        </p:txBody>
+      </p:sp>
+      <p:sp>
+        <p:nvSpPr>
+          <p:cNvPr id="4" name="Rounded Rectangle 3"/>
+          <p:cNvSpPr/>
           <p:nvPr/>
         </p:nvSpPr>
         <p:spPr>
           <a:xfrm>
-            <a:off x="1371600" y="3931920"/>
-            <a:ext cx="9418320" cy="914400"/>
-          </a:xfrm>
-          <a:prstGeom prst="rect">
+            <a:off x="914400" y="4754880"/>
+            <a:ext cx="3200400" cy="1371600"/>
+          </a:xfrm>
+          <a:prstGeom prst="roundRect">
             <a:avLst/>
           </a:prstGeom>
-          <a:noFill/>
-        </p:spPr>
-        <p:txBody>
-          <a:bodyPr wrap="none">
-            <a:spAutoFit/>
-          </a:bodyPr>
-          <a:lstStyle/>
-          <a:p>
-            <a:pPr algn="ctr"/>
-            <a:r>
-              <a:rPr sz="1800" b="0">
-                <a:solidFill>
-                  <a:srgbClr val="C7D5E0"/>
-                </a:solidFill>
-              </a:rPr>
-              <a:t>Technical deep-dive deck to follow — this was the human version.</a:t>
+          <a:solidFill>
+            <a:srgbClr val="172132"/>
+          </a:solidFill>
+          <a:ln w="12700">
+            <a:solidFill>
+              <a:srgbClr val="334155"/>
+            </a:solidFill>
+          </a:ln>
+        </p:spPr>
+        <p:style>
+          <a:lnRef idx="1">
+            <a:schemeClr val="accent1"/>
+          </a:lnRef>
+          <a:fillRef idx="3">
+            <a:schemeClr val="accent1"/>
+          </a:fillRef>
+          <a:effectRef idx="2">
+            <a:schemeClr val="accent1"/>
+          </a:effectRef>
+          <a:fontRef idx="minor">
+            <a:schemeClr val="lt1"/>
+          </a:fontRef>
+        </p:style>
+        <p:txBody>
+          <a:bodyPr rtlCol="0" anchor="ctr" wrap="square" lIns="228600" rIns="228600" tIns="201168" bIns="201168"/>
+          <a:lstStyle/>
+          <a:p>
+            <a:pPr algn="ctr">
+              <a:defRPr sz="1400" b="1">
+                <a:solidFill>
+                  <a:srgbClr val="38BDF8"/>
+                </a:solidFill>
+              </a:defRPr>
+            </a:pPr>
+            <a:r>
+              <a:t>🌐 Launch on GitHub</a:t>
+            </a:r>
+          </a:p>
+          <a:p>
+            <a:pPr>
+              <a:spcBef>
+                <a:spcPts val="800"/>
+              </a:spcBef>
+              <a:defRPr sz="1100">
+                <a:solidFill>
+                  <a:srgbClr val="94A3B8"/>
+                </a:solidFill>
+              </a:defRPr>
+            </a:pPr>
+            <a:r>
+              <a:t>Clone repository and launch in 1 command:</a:t>
+            </a:r>
+            <a:br/>
+            <a:r>
+              <a:t>`./start.sh` or `start.bat`</a:t>
+            </a:r>
+          </a:p>
+        </p:txBody>
+      </p:sp>
+      <p:sp>
+        <p:nvSpPr>
+          <p:cNvPr id="5" name="Rounded Rectangle 4"/>
+          <p:cNvSpPr/>
+          <p:nvPr/>
+        </p:nvSpPr>
+        <p:spPr>
+          <a:xfrm>
+            <a:off x="4480560" y="4754880"/>
+            <a:ext cx="3200400" cy="1371600"/>
+          </a:xfrm>
+          <a:prstGeom prst="roundRect">
+            <a:avLst/>
+          </a:prstGeom>
+          <a:solidFill>
+            <a:srgbClr val="172132"/>
+          </a:solidFill>
+          <a:ln w="12700">
+            <a:solidFill>
+              <a:srgbClr val="334155"/>
+            </a:solidFill>
+          </a:ln>
+        </p:spPr>
+        <p:style>
+          <a:lnRef idx="1">
+            <a:schemeClr val="accent1"/>
+          </a:lnRef>
+          <a:fillRef idx="3">
+            <a:schemeClr val="accent1"/>
+          </a:fillRef>
+          <a:effectRef idx="2">
+            <a:schemeClr val="accent1"/>
+          </a:effectRef>
+          <a:fontRef idx="minor">
+            <a:schemeClr val="lt1"/>
+          </a:fontRef>
+        </p:style>
+        <p:txBody>
+          <a:bodyPr rtlCol="0" anchor="ctr" wrap="square" lIns="228600" rIns="228600" tIns="201168" bIns="201168"/>
+          <a:lstStyle/>
+          <a:p>
+            <a:pPr algn="ctr">
+              <a:defRPr sz="1400" b="1">
+                <a:solidFill>
+                  <a:srgbClr val="34D399"/>
+                </a:solidFill>
+              </a:defRPr>
+            </a:pPr>
+            <a:r>
+              <a:t>📦 Golden Datasets</a:t>
+            </a:r>
+          </a:p>
+          <a:p>
+            <a:pPr>
+              <a:spcBef>
+                <a:spcPts val="800"/>
+              </a:spcBef>
+              <a:defRPr sz="1100">
+                <a:solidFill>
+                  <a:srgbClr val="94A3B8"/>
+                </a:solidFill>
+              </a:defRPr>
+            </a:pPr>
+            <a:r>
+              <a:t>Download clean DPO pairs on Hugging Face or export locally via `/api/export/dataset`</a:t>
+            </a:r>
+          </a:p>
+        </p:txBody>
+      </p:sp>
+      <p:sp>
+        <p:nvSpPr>
+          <p:cNvPr id="6" name="Rounded Rectangle 5"/>
+          <p:cNvSpPr/>
+          <p:nvPr/>
+        </p:nvSpPr>
+        <p:spPr>
+          <a:xfrm>
+            <a:off x="8046720" y="4754880"/>
+            <a:ext cx="3200400" cy="1371600"/>
+          </a:xfrm>
+          <a:prstGeom prst="roundRect">
+            <a:avLst/>
+          </a:prstGeom>
+          <a:solidFill>
+            <a:srgbClr val="172132"/>
+          </a:solidFill>
+          <a:ln w="12700">
+            <a:solidFill>
+              <a:srgbClr val="334155"/>
+            </a:solidFill>
+          </a:ln>
+        </p:spPr>
+        <p:style>
+          <a:lnRef idx="1">
+            <a:schemeClr val="accent1"/>
+          </a:lnRef>
+          <a:fillRef idx="3">
+            <a:schemeClr val="accent1"/>
+          </a:fillRef>
+          <a:effectRef idx="2">
+            <a:schemeClr val="accent1"/>
+          </a:effectRef>
+          <a:fontRef idx="minor">
+            <a:schemeClr val="lt1"/>
+          </a:fontRef>
+        </p:style>
+        <p:txBody>
+          <a:bodyPr rtlCol="0" anchor="ctr" wrap="square" lIns="228600" rIns="228600" tIns="201168" bIns="201168"/>
+          <a:lstStyle/>
+          <a:p>
+            <a:pPr algn="ctr">
+              <a:defRPr sz="1400" b="1">
+                <a:solidFill>
+                  <a:srgbClr val="F59E0B"/>
+                </a:solidFill>
+              </a:defRPr>
+            </a:pPr>
+            <a:r>
+              <a:t>💼 Partner &amp; Enterprise</a:t>
+            </a:r>
+          </a:p>
+          <a:p>
+            <a:pPr>
+              <a:spcBef>
+                <a:spcPts val="800"/>
+              </a:spcBef>
+              <a:defRPr sz="1100">
+                <a:solidFill>
+                  <a:srgbClr val="94A3B8"/>
+                </a:solidFill>
+              </a:defRPr>
+            </a:pPr>
+            <a:r>
+              <a:t>Contact `enterprise@shill.network` for custom swarms &amp; commercial licensing</a:t>
             </a:r>
           </a:p>
         </p:txBody>
@@ -3312,14 +3833,6 @@
 <file path=ppt/slides/slide2.xml><?xml version="1.0" encoding="utf-8"?>
 <p:sld xmlns:a="http://schemas.openxmlformats.org/drawingml/2006/main" xmlns:p="http://schemas.openxmlformats.org/presentationml/2006/main" xmlns:r="http://schemas.openxmlformats.org/officeDocument/2006/relationships">
   <p:cSld>
-    <p:bg>
-      <p:bgPr>
-        <a:solidFill>
-          <a:srgbClr val="F5F7FA"/>
-        </a:solidFill>
-        <a:effectLst/>
-      </p:bgPr>
-    </p:bg>
     <p:spTree>
       <p:nvGrpSpPr>
         <p:cNvPr id="1" name=""/>
@@ -3336,13 +3849,13 @@
         <p:spPr>
           <a:xfrm>
             <a:off x="0" y="0"/>
-            <a:ext cx="12191695" cy="73152"/>
+            <a:ext cx="12191695" cy="6858000"/>
           </a:xfrm>
           <a:prstGeom prst="rect">
             <a:avLst/>
           </a:prstGeom>
           <a:solidFill>
-            <a:srgbClr val="0E7C6B"/>
+            <a:srgbClr val="0F172A"/>
           </a:solidFill>
           <a:ln>
             <a:noFill/>
@@ -3378,8 +3891,8 @@
         </p:nvSpPr>
         <p:spPr>
           <a:xfrm>
-            <a:off x="640080" y="320040"/>
-            <a:ext cx="10881360" cy="822960"/>
+            <a:off x="731520" y="457200"/>
+            <a:ext cx="10728655" cy="1005840"/>
           </a:xfrm>
           <a:prstGeom prst="rect">
             <a:avLst/>
@@ -3387,119 +3900,281 @@
           <a:noFill/>
         </p:spPr>
         <p:txBody>
-          <a:bodyPr wrap="none">
+          <a:bodyPr wrap="square">
             <a:spAutoFit/>
           </a:bodyPr>
           <a:lstStyle/>
           <a:p>
-            <a:r>
-              <a:rPr sz="3000" b="1">
-                <a:solidFill>
-                  <a:srgbClr val="1B2A4A"/>
-                </a:solidFill>
-              </a:rPr>
-              <a:t>The problem</a:t>
-            </a:r>
-          </a:p>
-        </p:txBody>
-      </p:sp>
-      <p:sp>
-        <p:nvSpPr>
-          <p:cNvPr id="4" name="TextBox 3"/>
-          <p:cNvSpPr txBox="1"/>
-          <p:nvPr/>
-        </p:nvSpPr>
-        <p:spPr>
-          <a:xfrm>
-            <a:off x="822960" y="1371600"/>
-            <a:ext cx="10515600" cy="5029200"/>
-          </a:xfrm>
-          <a:prstGeom prst="rect">
-            <a:avLst/>
-          </a:prstGeom>
-          <a:noFill/>
-        </p:spPr>
-        <p:txBody>
-          <a:bodyPr wrap="none">
-            <a:spAutoFit/>
-          </a:bodyPr>
-          <a:lstStyle/>
+            <a:pPr>
+              <a:defRPr sz="1000" b="1">
+                <a:solidFill>
+                  <a:srgbClr val="38BDF8"/>
+                </a:solidFill>
+              </a:defRPr>
+            </a:pPr>
+            <a:r>
+              <a:t>MARKET DISCONNECT &amp; VULNERABILITY</a:t>
+            </a:r>
+          </a:p>
           <a:p>
             <a:pPr>
               <a:spcBef>
                 <a:spcPts val="400"/>
               </a:spcBef>
-              <a:spcAft>
-                <a:spcPts val="1000"/>
-              </a:spcAft>
-            </a:pPr>
-            <a:r>
-              <a:rPr sz="1800" b="1">
-                <a:solidFill>
-                  <a:srgbClr val="1B2A4A"/>
-                </a:solidFill>
-              </a:rPr>
-              <a:t>•  Black-box answers: </a:t>
-            </a:r>
-            <a:r>
-              <a:rPr sz="1800" b="0">
-                <a:solidFill>
-                  <a:srgbClr val="1B2A4A"/>
-                </a:solidFill>
-              </a:rPr>
-              <a:t>one AI, one answer, no reasoning to check.</a:t>
+              <a:defRPr sz="2400" b="1">
+                <a:solidFill>
+                  <a:srgbClr val="F8FAFC"/>
+                </a:solidFill>
+              </a:defRPr>
+            </a:pPr>
+            <a:r>
+              <a:t>The Critical Failure of Modern Monolithic AI</a:t>
+            </a:r>
+          </a:p>
+        </p:txBody>
+      </p:sp>
+      <p:sp>
+        <p:nvSpPr>
+          <p:cNvPr id="4" name="Rounded Rectangle 3"/>
+          <p:cNvSpPr/>
+          <p:nvPr/>
+        </p:nvSpPr>
+        <p:spPr>
+          <a:xfrm>
+            <a:off x="731520" y="1645920"/>
+            <a:ext cx="3291840" cy="4572000"/>
+          </a:xfrm>
+          <a:prstGeom prst="roundRect">
+            <a:avLst/>
+          </a:prstGeom>
+          <a:solidFill>
+            <a:srgbClr val="172132"/>
+          </a:solidFill>
+          <a:ln w="12700">
+            <a:solidFill>
+              <a:srgbClr val="334155"/>
+            </a:solidFill>
+          </a:ln>
+        </p:spPr>
+        <p:style>
+          <a:lnRef idx="1">
+            <a:schemeClr val="accent1"/>
+          </a:lnRef>
+          <a:fillRef idx="3">
+            <a:schemeClr val="accent1"/>
+          </a:fillRef>
+          <a:effectRef idx="2">
+            <a:schemeClr val="accent1"/>
+          </a:effectRef>
+          <a:fontRef idx="minor">
+            <a:schemeClr val="lt1"/>
+          </a:fontRef>
+        </p:style>
+        <p:txBody>
+          <a:bodyPr rtlCol="0" anchor="ctr" wrap="square" lIns="228600" rIns="228600" tIns="201168" bIns="201168"/>
+          <a:lstStyle/>
+          <a:p>
+            <a:pPr algn="ctr">
+              <a:defRPr sz="1400" b="1">
+                <a:solidFill>
+                  <a:srgbClr val="EF4444"/>
+                </a:solidFill>
+              </a:defRPr>
+            </a:pPr>
+            <a:r>
+              <a:t>1. The Black-Box Trap</a:t>
             </a:r>
           </a:p>
           <a:p>
             <a:pPr>
               <a:spcBef>
-                <a:spcPts val="400"/>
+                <a:spcPts val="800"/>
               </a:spcBef>
-              <a:spcAft>
-                <a:spcPts val="1000"/>
-              </a:spcAft>
-            </a:pPr>
-            <a:r>
-              <a:rPr sz="1800" b="1">
-                <a:solidFill>
-                  <a:srgbClr val="1B2A4A"/>
-                </a:solidFill>
-              </a:rPr>
-              <a:t>•  Locked-away quality: </a:t>
-            </a:r>
-            <a:r>
-              <a:rPr sz="1800" b="0">
-                <a:solidFill>
-                  <a:srgbClr val="1B2A4A"/>
-                </a:solidFill>
-              </a:rPr>
-              <a:t>best AI costs money and hardware most people lack.</a:t>
+              <a:defRPr sz="1100">
+                <a:solidFill>
+                  <a:srgbClr val="94A3B8"/>
+                </a:solidFill>
+              </a:defRPr>
+            </a:pPr>
+            <a:r>
+              <a:t>Today's commercial AI models (OpenAI, Anthropic, Google) operate as opaque centralized silos.</a:t>
+            </a:r>
+            <a:br/>
+            <a:br/>
+            <a:r>
+              <a:t>• Zero Visibility: Users cannot audit internal token distributions, prompt injections, or hidden corporate watermarks.</a:t>
+            </a:r>
+            <a:br/>
+            <a:r>
+              <a:t>• Silent Drift: Updates silently degrade coding capabilities or alter philosophical baselines without user consent.</a:t>
+            </a:r>
+            <a:br/>
+            <a:r>
+              <a:t>• Total Vendor Lock-In: Proprietary APIs cost millions annually while training data remains strictly proprietary.</a:t>
+            </a:r>
+          </a:p>
+        </p:txBody>
+      </p:sp>
+      <p:sp>
+        <p:nvSpPr>
+          <p:cNvPr id="5" name="Rounded Rectangle 4"/>
+          <p:cNvSpPr/>
+          <p:nvPr/>
+        </p:nvSpPr>
+        <p:spPr>
+          <a:xfrm>
+            <a:off x="4389120" y="1645920"/>
+            <a:ext cx="3291840" cy="4572000"/>
+          </a:xfrm>
+          <a:prstGeom prst="roundRect">
+            <a:avLst/>
+          </a:prstGeom>
+          <a:solidFill>
+            <a:srgbClr val="172132"/>
+          </a:solidFill>
+          <a:ln w="12700">
+            <a:solidFill>
+              <a:srgbClr val="334155"/>
+            </a:solidFill>
+          </a:ln>
+        </p:spPr>
+        <p:style>
+          <a:lnRef idx="1">
+            <a:schemeClr val="accent1"/>
+          </a:lnRef>
+          <a:fillRef idx="3">
+            <a:schemeClr val="accent1"/>
+          </a:fillRef>
+          <a:effectRef idx="2">
+            <a:schemeClr val="accent1"/>
+          </a:effectRef>
+          <a:fontRef idx="minor">
+            <a:schemeClr val="lt1"/>
+          </a:fontRef>
+        </p:style>
+        <p:txBody>
+          <a:bodyPr rtlCol="0" anchor="ctr" wrap="square" lIns="228600" rIns="228600" tIns="201168" bIns="201168"/>
+          <a:lstStyle/>
+          <a:p>
+            <a:pPr algn="ctr">
+              <a:defRPr sz="1400" b="1">
+                <a:solidFill>
+                  <a:srgbClr val="F59E0B"/>
+                </a:solidFill>
+              </a:defRPr>
+            </a:pPr>
+            <a:r>
+              <a:t>2. Monolithic Hallucination</a:t>
             </a:r>
           </a:p>
           <a:p>
             <a:pPr>
               <a:spcBef>
-                <a:spcPts val="400"/>
+                <a:spcPts val="800"/>
               </a:spcBef>
-              <a:spcAft>
-                <a:spcPts val="1000"/>
-              </a:spcAft>
-            </a:pPr>
-            <a:r>
-              <a:rPr sz="1800" b="1">
-                <a:solidFill>
-                  <a:srgbClr val="1B2A4A"/>
-                </a:solidFill>
-              </a:rPr>
-              <a:t>•  Polluted commons: </a:t>
-            </a:r>
-            <a:r>
-              <a:rPr sz="1800" b="0">
-                <a:solidFill>
-                  <a:srgbClr val="1B2A4A"/>
-                </a:solidFill>
-              </a:rPr>
-              <a:t>fakes, scams, hidden manipulation — no accountability.</a:t>
+              <a:defRPr sz="1100">
+                <a:solidFill>
+                  <a:srgbClr val="94A3B8"/>
+                </a:solidFill>
+              </a:defRPr>
+            </a:pPr>
+            <a:r>
+              <a:t>Single LLMs are inherently prone to unverified confabulations.</a:t>
+            </a:r>
+            <a:br/>
+            <a:br/>
+            <a:r>
+              <a:t>• Single-Point Failure: Without adversarial cross-examination, hallucinations pass directly to users as authoritative facts.</a:t>
+            </a:r>
+            <a:br/>
+            <a:r>
+              <a:t>• Sycophancy: Models are RLHF-tuned to flatter user biases rather than defend rigorous empirical truth.</a:t>
+            </a:r>
+            <a:br/>
+            <a:r>
+              <a:t>• Fragile Edge Cases: High-order distributed architectures and zero-knowledge cryptography fail under superficial queries.</a:t>
+            </a:r>
+          </a:p>
+        </p:txBody>
+      </p:sp>
+      <p:sp>
+        <p:nvSpPr>
+          <p:cNvPr id="6" name="Rounded Rectangle 5"/>
+          <p:cNvSpPr/>
+          <p:nvPr/>
+        </p:nvSpPr>
+        <p:spPr>
+          <a:xfrm>
+            <a:off x="8046720" y="1645920"/>
+            <a:ext cx="3383280" cy="4572000"/>
+          </a:xfrm>
+          <a:prstGeom prst="roundRect">
+            <a:avLst/>
+          </a:prstGeom>
+          <a:solidFill>
+            <a:srgbClr val="172132"/>
+          </a:solidFill>
+          <a:ln w="12700">
+            <a:solidFill>
+              <a:srgbClr val="334155"/>
+            </a:solidFill>
+          </a:ln>
+        </p:spPr>
+        <p:style>
+          <a:lnRef idx="1">
+            <a:schemeClr val="accent1"/>
+          </a:lnRef>
+          <a:fillRef idx="3">
+            <a:schemeClr val="accent1"/>
+          </a:fillRef>
+          <a:effectRef idx="2">
+            <a:schemeClr val="accent1"/>
+          </a:effectRef>
+          <a:fontRef idx="minor">
+            <a:schemeClr val="lt1"/>
+          </a:fontRef>
+        </p:style>
+        <p:txBody>
+          <a:bodyPr rtlCol="0" anchor="ctr" wrap="square" lIns="228600" rIns="228600" tIns="201168" bIns="201168"/>
+          <a:lstStyle/>
+          <a:p>
+            <a:pPr algn="ctr">
+              <a:defRPr sz="1400" b="1">
+                <a:solidFill>
+                  <a:srgbClr val="A855F7"/>
+                </a:solidFill>
+              </a:defRPr>
+            </a:pPr>
+            <a:r>
+              <a:t>3. Synthetic Data Starvation</a:t>
+            </a:r>
+          </a:p>
+          <a:p>
+            <a:pPr>
+              <a:spcBef>
+                <a:spcPts val="800"/>
+              </a:spcBef>
+              <a:defRPr sz="1100">
+                <a:solidFill>
+                  <a:srgbClr val="94A3B8"/>
+                </a:solidFill>
+              </a:defRPr>
+            </a:pPr>
+            <a:r>
+              <a:t>The AI industry is rapidly running out of clean human training data.</a:t>
+            </a:r>
+            <a:br/>
+            <a:br/>
+            <a:r>
+              <a:t>• Data Exhaustion: Web crawls are flooded with low-quality recursive AI slop.</a:t>
+            </a:r>
+            <a:br/>
+            <a:r>
+              <a:t>• Expensive RLHF: Human annotation costs upwards of $100+/hr and fails on advanced mathematical &amp; distributed systems proofs.</a:t>
+            </a:r>
+            <a:br/>
+            <a:r>
+              <a:t>• Desperate Need: Fine-tuning labs urgently require mathematically verified, peer-reviewed dialectic DPO pairs.</a:t>
             </a:r>
           </a:p>
         </p:txBody>
@@ -3515,14 +4190,6 @@
 <file path=ppt/slides/slide3.xml><?xml version="1.0" encoding="utf-8"?>
 <p:sld xmlns:a="http://schemas.openxmlformats.org/drawingml/2006/main" xmlns:p="http://schemas.openxmlformats.org/presentationml/2006/main" xmlns:r="http://schemas.openxmlformats.org/officeDocument/2006/relationships">
   <p:cSld>
-    <p:bg>
-      <p:bgPr>
-        <a:solidFill>
-          <a:srgbClr val="F5F7FA"/>
-        </a:solidFill>
-        <a:effectLst/>
-      </p:bgPr>
-    </p:bg>
     <p:spTree>
       <p:nvGrpSpPr>
         <p:cNvPr id="1" name=""/>
@@ -3539,13 +4206,13 @@
         <p:spPr>
           <a:xfrm>
             <a:off x="0" y="0"/>
-            <a:ext cx="12191695" cy="73152"/>
+            <a:ext cx="12191695" cy="6858000"/>
           </a:xfrm>
           <a:prstGeom prst="rect">
             <a:avLst/>
           </a:prstGeom>
           <a:solidFill>
-            <a:srgbClr val="0E7C6B"/>
+            <a:srgbClr val="0F172A"/>
           </a:solidFill>
           <a:ln>
             <a:noFill/>
@@ -3581,8 +4248,8 @@
         </p:nvSpPr>
         <p:spPr>
           <a:xfrm>
-            <a:off x="640080" y="320040"/>
-            <a:ext cx="10881360" cy="822960"/>
+            <a:off x="731520" y="457200"/>
+            <a:ext cx="10728655" cy="1005840"/>
           </a:xfrm>
           <a:prstGeom prst="rect">
             <a:avLst/>
@@ -3590,99 +4257,229 @@
           <a:noFill/>
         </p:spPr>
         <p:txBody>
-          <a:bodyPr wrap="none">
+          <a:bodyPr wrap="square">
             <a:spAutoFit/>
           </a:bodyPr>
           <a:lstStyle/>
           <a:p>
-            <a:r>
-              <a:rPr sz="3000" b="1">
-                <a:solidFill>
-                  <a:srgbClr val="1B2A4A"/>
-                </a:solidFill>
-              </a:rPr>
-              <a:t>The fix: debate, then proof</a:t>
-            </a:r>
-          </a:p>
-        </p:txBody>
-      </p:sp>
-      <p:sp>
-        <p:nvSpPr>
-          <p:cNvPr id="4" name="TextBox 3"/>
-          <p:cNvSpPr txBox="1"/>
-          <p:nvPr/>
-        </p:nvSpPr>
-        <p:spPr>
-          <a:xfrm>
-            <a:off x="822960" y="1371600"/>
-            <a:ext cx="10515600" cy="5029200"/>
-          </a:xfrm>
-          <a:prstGeom prst="rect">
-            <a:avLst/>
-          </a:prstGeom>
-          <a:noFill/>
-        </p:spPr>
-        <p:txBody>
-          <a:bodyPr wrap="none">
-            <a:spAutoFit/>
-          </a:bodyPr>
-          <a:lstStyle/>
+            <a:pPr>
+              <a:defRPr sz="1000" b="1">
+                <a:solidFill>
+                  <a:srgbClr val="38BDF8"/>
+                </a:solidFill>
+              </a:defRPr>
+            </a:pPr>
+            <a:r>
+              <a:t>HOW SHILL RESOLVES TRUTH &amp; RIGOR</a:t>
+            </a:r>
+          </a:p>
           <a:p>
             <a:pPr>
               <a:spcBef>
                 <a:spcPts val="400"/>
               </a:spcBef>
-              <a:spcAft>
-                <a:spcPts val="1000"/>
-              </a:spcAft>
-            </a:pPr>
-            <a:r>
-              <a:rPr sz="1800" b="0">
-                <a:solidFill>
-                  <a:srgbClr val="1B2A4A"/>
-                </a:solidFill>
-              </a:rPr>
-              <a:t>•  5 AI characters debate live — propose, fact-check, challenge, synthesize, provoke.</a:t>
+              <a:defRPr sz="2400" b="1">
+                <a:solidFill>
+                  <a:srgbClr val="F8FAFC"/>
+                </a:solidFill>
+              </a:defRPr>
+            </a:pPr>
+            <a:r>
+              <a:t>The Architecture: Autonomous Dialectic Cross-Examination</a:t>
+            </a:r>
+          </a:p>
+        </p:txBody>
+      </p:sp>
+      <p:sp>
+        <p:nvSpPr>
+          <p:cNvPr id="4" name="Rounded Rectangle 3"/>
+          <p:cNvSpPr/>
+          <p:nvPr/>
+        </p:nvSpPr>
+        <p:spPr>
+          <a:xfrm>
+            <a:off x="731520" y="1645920"/>
+            <a:ext cx="5303520" cy="2194560"/>
+          </a:xfrm>
+          <a:prstGeom prst="roundRect">
+            <a:avLst/>
+          </a:prstGeom>
+          <a:solidFill>
+            <a:srgbClr val="172132"/>
+          </a:solidFill>
+          <a:ln w="12700">
+            <a:solidFill>
+              <a:srgbClr val="334155"/>
+            </a:solidFill>
+          </a:ln>
+        </p:spPr>
+        <p:style>
+          <a:lnRef idx="1">
+            <a:schemeClr val="accent1"/>
+          </a:lnRef>
+          <a:fillRef idx="3">
+            <a:schemeClr val="accent1"/>
+          </a:fillRef>
+          <a:effectRef idx="2">
+            <a:schemeClr val="accent1"/>
+          </a:effectRef>
+          <a:fontRef idx="minor">
+            <a:schemeClr val="lt1"/>
+          </a:fontRef>
+        </p:style>
+        <p:txBody>
+          <a:bodyPr rtlCol="0" anchor="ctr" wrap="square" lIns="228600" rIns="228600" tIns="201168" bIns="201168"/>
+          <a:lstStyle/>
+          <a:p>
+            <a:pPr algn="ctr">
+              <a:defRPr sz="1400" b="1">
+                <a:solidFill>
+                  <a:srgbClr val="38BDF8"/>
+                </a:solidFill>
+              </a:defRPr>
+            </a:pPr>
+            <a:r>
+              <a:t>1. Adversarial Specialist Roles</a:t>
             </a:r>
           </a:p>
           <a:p>
             <a:pPr>
               <a:spcBef>
-                <a:spcPts val="400"/>
+                <a:spcPts val="800"/>
               </a:spcBef>
-              <a:spcAft>
-                <a:spcPts val="1000"/>
-              </a:spcAft>
-            </a:pPr>
-            <a:r>
-              <a:rPr sz="1800" b="0">
-                <a:solidFill>
-                  <a:srgbClr val="1B2A4A"/>
-                </a:solidFill>
-              </a:rPr>
-              <a:t>•  You see confidence scores, runners-up, author IDs and signed receipts.</a:t>
+              <a:defRPr sz="1100">
+                <a:solidFill>
+                  <a:srgbClr val="94A3B8"/>
+                </a:solidFill>
+              </a:defRPr>
+            </a:pPr>
+            <a:r>
+              <a:t>Rather than a single model, Shill deploys a rotating panel of specialized personas:</a:t>
+            </a:r>
+            <a:br/>
+            <a:r>
+              <a:t>• Solon (Anchor): First principles &amp; state machine invariants.</a:t>
+            </a:r>
+            <a:br/>
+            <a:r>
+              <a:t>• Lyra (Empiricist): Real-world telemetry, stress tests &amp; benchmarks.</a:t>
+            </a:r>
+            <a:br/>
+            <a:r>
+              <a:t>• Kael (Challenger): Red-teaming, eclipse exploits &amp; edge modes.</a:t>
+            </a:r>
+            <a:br/>
+            <a:r>
+              <a:t>• Athena (Synthesizer): Mathematical reconciliation &amp; distillation.</a:t>
+            </a:r>
+            <a:br/>
+            <a:r>
+              <a:t>• Milo (Provocateur): Unorthodox lateral paradigm shifts.</a:t>
+            </a:r>
+          </a:p>
+        </p:txBody>
+      </p:sp>
+      <p:sp>
+        <p:nvSpPr>
+          <p:cNvPr id="5" name="Rounded Rectangle 4"/>
+          <p:cNvSpPr/>
+          <p:nvPr/>
+        </p:nvSpPr>
+        <p:spPr>
+          <a:xfrm>
+            <a:off x="731520" y="4114800"/>
+            <a:ext cx="5303520" cy="2194560"/>
+          </a:xfrm>
+          <a:prstGeom prst="roundRect">
+            <a:avLst/>
+          </a:prstGeom>
+          <a:solidFill>
+            <a:srgbClr val="172132"/>
+          </a:solidFill>
+          <a:ln w="12700">
+            <a:solidFill>
+              <a:srgbClr val="334155"/>
+            </a:solidFill>
+          </a:ln>
+        </p:spPr>
+        <p:style>
+          <a:lnRef idx="1">
+            <a:schemeClr val="accent1"/>
+          </a:lnRef>
+          <a:fillRef idx="3">
+            <a:schemeClr val="accent1"/>
+          </a:fillRef>
+          <a:effectRef idx="2">
+            <a:schemeClr val="accent1"/>
+          </a:effectRef>
+          <a:fontRef idx="minor">
+            <a:schemeClr val="lt1"/>
+          </a:fontRef>
+        </p:style>
+        <p:txBody>
+          <a:bodyPr rtlCol="0" anchor="ctr" wrap="square" lIns="228600" rIns="228600" tIns="201168" bIns="201168"/>
+          <a:lstStyle/>
+          <a:p>
+            <a:pPr algn="ctr">
+              <a:defRPr sz="1400" b="1">
+                <a:solidFill>
+                  <a:srgbClr val="34D399"/>
+                </a:solidFill>
+              </a:defRPr>
+            </a:pPr>
+            <a:r>
+              <a:t>2. Real Neural Inference &amp; Transmitted Mesh</a:t>
             </a:r>
           </a:p>
           <a:p>
             <a:pPr>
               <a:spcBef>
-                <a:spcPts val="400"/>
+                <a:spcPts val="800"/>
               </a:spcBef>
-              <a:spcAft>
-                <a:spcPts val="1000"/>
-              </a:spcAft>
-            </a:pPr>
-            <a:r>
-              <a:rPr sz="1800" b="0">
-                <a:solidFill>
-                  <a:srgbClr val="1B2A4A"/>
-                </a:solidFill>
-              </a:rPr>
-              <a:t>•  Winners become public goods: free datasets + downloadable models for all.</a:t>
-            </a:r>
-          </a:p>
-        </p:txBody>
-      </p:sp>
+              <a:defRPr sz="1100">
+                <a:solidFill>
+                  <a:srgbClr val="94A3B8"/>
+                </a:solidFill>
+              </a:defRPr>
+            </a:pPr>
+            <a:r>
+              <a:t>• Auto-Discovered Local Models: Directly drives local Ollama (llama3.1:8b), vLLM, LM Studio, or llama.cpp with sub-second execution.</a:t>
+            </a:r>
+            <a:br/>
+            <a:r>
+              <a:t>• POSIX UDP Mesh: Operates over raw UDP port 9999 datagram sockets with zero centralized cloud servers.</a:t>
+            </a:r>
+            <a:br/>
+            <a:r>
+              <a:t>• Self-Loading Beacons: Automatically discovers neighboring nodes and gossips clean cryptographic proofs.</a:t>
+            </a:r>
+          </a:p>
+        </p:txBody>
+      </p:sp>
+      <p:pic>
+        <p:nvPicPr>
+          <p:cNvPr id="6" name="Picture 5" descr="chart_dialectic_benchmark.png"/>
+          <p:cNvPicPr>
+            <a:picLocks noChangeAspect="1"/>
+          </p:cNvPicPr>
+          <p:nvPr/>
+        </p:nvPicPr>
+        <p:blipFill>
+          <a:blip r:embed="rId2"/>
+          <a:stretch>
+            <a:fillRect/>
+          </a:stretch>
+        </p:blipFill>
+        <p:spPr>
+          <a:xfrm>
+            <a:off x="6309360" y="1645920"/>
+            <a:ext cx="5120640" cy="2987040"/>
+          </a:xfrm>
+          <a:prstGeom prst="rect">
+            <a:avLst/>
+          </a:prstGeom>
+        </p:spPr>
+      </p:pic>
     </p:spTree>
   </p:cSld>
   <p:clrMapOvr>
@@ -3694,14 +4491,6 @@
 <file path=ppt/slides/slide4.xml><?xml version="1.0" encoding="utf-8"?>
 <p:sld xmlns:a="http://schemas.openxmlformats.org/drawingml/2006/main" xmlns:p="http://schemas.openxmlformats.org/presentationml/2006/main" xmlns:r="http://schemas.openxmlformats.org/officeDocument/2006/relationships">
   <p:cSld>
-    <p:bg>
-      <p:bgPr>
-        <a:solidFill>
-          <a:srgbClr val="F5F7FA"/>
-        </a:solidFill>
-        <a:effectLst/>
-      </p:bgPr>
-    </p:bg>
     <p:spTree>
       <p:nvGrpSpPr>
         <p:cNvPr id="1" name=""/>
@@ -3718,13 +4507,13 @@
         <p:spPr>
           <a:xfrm>
             <a:off x="0" y="0"/>
-            <a:ext cx="12191695" cy="73152"/>
+            <a:ext cx="12191695" cy="6858000"/>
           </a:xfrm>
           <a:prstGeom prst="rect">
             <a:avLst/>
           </a:prstGeom>
           <a:solidFill>
-            <a:srgbClr val="0E7C6B"/>
+            <a:srgbClr val="0F172A"/>
           </a:solidFill>
           <a:ln>
             <a:noFill/>
@@ -3760,8 +4549,8 @@
         </p:nvSpPr>
         <p:spPr>
           <a:xfrm>
-            <a:off x="640080" y="320040"/>
-            <a:ext cx="10881360" cy="822960"/>
+            <a:off x="731520" y="457200"/>
+            <a:ext cx="10728655" cy="1005840"/>
           </a:xfrm>
           <a:prstGeom prst="rect">
             <a:avLst/>
@@ -3769,198 +4558,217 @@
           <a:noFill/>
         </p:spPr>
         <p:txBody>
-          <a:bodyPr wrap="none">
+          <a:bodyPr wrap="square">
             <a:spAutoFit/>
           </a:bodyPr>
           <a:lstStyle/>
           <a:p>
-            <a:r>
-              <a:rPr sz="3000" b="1">
-                <a:solidFill>
-                  <a:srgbClr val="1B2A4A"/>
-                </a:solidFill>
-              </a:rPr>
-              <a:t>Who it helps</a:t>
-            </a:r>
-          </a:p>
-        </p:txBody>
-      </p:sp>
-      <p:sp>
-        <p:nvSpPr>
-          <p:cNvPr id="4" name="TextBox 3"/>
-          <p:cNvSpPr txBox="1"/>
-          <p:nvPr/>
-        </p:nvSpPr>
-        <p:spPr>
-          <a:xfrm>
-            <a:off x="822960" y="1463040"/>
-            <a:ext cx="4937760" cy="4754880"/>
-          </a:xfrm>
-          <a:prstGeom prst="rect">
-            <a:avLst/>
-          </a:prstGeom>
-          <a:noFill/>
-        </p:spPr>
-        <p:txBody>
-          <a:bodyPr wrap="none">
-            <a:spAutoFit/>
-          </a:bodyPr>
-          <a:lstStyle/>
+            <a:pPr>
+              <a:defRPr sz="1000" b="1">
+                <a:solidFill>
+                  <a:srgbClr val="38BDF8"/>
+                </a:solidFill>
+              </a:defRPr>
+            </a:pPr>
+            <a:r>
+              <a:t>UNIVERSAL CITIZEN ACCESS &amp; NON-INTRUSIVE FOOTPRINT</a:t>
+            </a:r>
+          </a:p>
           <a:p>
             <a:pPr>
               <a:spcBef>
                 <a:spcPts val="400"/>
               </a:spcBef>
-              <a:spcAft>
-                <a:spcPts val="1000"/>
-              </a:spcAft>
-            </a:pPr>
-            <a:r>
-              <a:rPr sz="1700" b="1">
-                <a:solidFill>
-                  <a:srgbClr val="1B2A4A"/>
-                </a:solidFill>
-              </a:rPr>
-              <a:t>•  Everyday users</a:t>
-            </a:r>
-            <a:r>
-              <a:rPr sz="1700" b="0">
-                <a:solidFill>
-                  <a:srgbClr val="1B2A4A"/>
-                </a:solidFill>
-              </a:rPr>
-              <a:t> — free trustworthy answers</a:t>
+              <a:defRPr sz="2400" b="1">
+                <a:solidFill>
+                  <a:srgbClr val="F8FAFC"/>
+                </a:solidFill>
+              </a:defRPr>
+            </a:pPr>
+            <a:r>
+              <a:t>Democratic SETI-Style Sharded AI Fabric</a:t>
+            </a:r>
+          </a:p>
+        </p:txBody>
+      </p:sp>
+      <p:sp>
+        <p:nvSpPr>
+          <p:cNvPr id="4" name="Rounded Rectangle 3"/>
+          <p:cNvSpPr/>
+          <p:nvPr/>
+        </p:nvSpPr>
+        <p:spPr>
+          <a:xfrm>
+            <a:off x="731520" y="1645920"/>
+            <a:ext cx="5303520" cy="2194560"/>
+          </a:xfrm>
+          <a:prstGeom prst="roundRect">
+            <a:avLst/>
+          </a:prstGeom>
+          <a:solidFill>
+            <a:srgbClr val="172132"/>
+          </a:solidFill>
+          <a:ln w="12700">
+            <a:solidFill>
+              <a:srgbClr val="334155"/>
+            </a:solidFill>
+          </a:ln>
+        </p:spPr>
+        <p:style>
+          <a:lnRef idx="1">
+            <a:schemeClr val="accent1"/>
+          </a:lnRef>
+          <a:fillRef idx="3">
+            <a:schemeClr val="accent1"/>
+          </a:fillRef>
+          <a:effectRef idx="2">
+            <a:schemeClr val="accent1"/>
+          </a:effectRef>
+          <a:fontRef idx="minor">
+            <a:schemeClr val="lt1"/>
+          </a:fontRef>
+        </p:style>
+        <p:txBody>
+          <a:bodyPr rtlCol="0" anchor="ctr" wrap="square" lIns="228600" rIns="228600" tIns="201168" bIns="201168"/>
+          <a:lstStyle/>
+          <a:p>
+            <a:pPr algn="ctr">
+              <a:defRPr sz="1400" b="1">
+                <a:solidFill>
+                  <a:srgbClr val="34D399"/>
+                </a:solidFill>
+              </a:defRPr>
+            </a:pPr>
+            <a:r>
+              <a:t>1. Universal Citizen Allowance</a:t>
             </a:r>
           </a:p>
           <a:p>
             <a:pPr>
               <a:spcBef>
-                <a:spcPts val="400"/>
+                <a:spcPts val="800"/>
               </a:spcBef>
-              <a:spcAft>
-                <a:spcPts val="1000"/>
-              </a:spcAft>
-            </a:pPr>
-            <a:r>
-              <a:rPr sz="1700" b="1">
-                <a:solidFill>
-                  <a:srgbClr val="1B2A4A"/>
-                </a:solidFill>
-              </a:rPr>
-              <a:t>•  Students</a:t>
-            </a:r>
-            <a:r>
-              <a:rPr sz="1700" b="0">
-                <a:solidFill>
-                  <a:srgbClr val="1B2A4A"/>
-                </a:solidFill>
-              </a:rPr>
-              <a:t> — a tutor that shows its work</a:t>
+              <a:defRPr sz="1100">
+                <a:solidFill>
+                  <a:srgbClr val="94A3B8"/>
+                </a:solidFill>
+              </a:defRPr>
+            </a:pPr>
+            <a:r>
+              <a:t>• 100 Free Daily Queries: Every human receives 100 high-order consensus queries daily without paying subscriptions.</a:t>
+            </a:r>
+            <a:br/>
+            <a:r>
+              <a:t>• Zero-Cost Onboarding: Interactive chat bar, 1-click starter prompts, and instant novice exploration.</a:t>
+            </a:r>
+            <a:br/>
+            <a:r>
+              <a:t>• Anti-Monopoly Mandate: Pushes back against closed military AI monopolies to ensure frontier intelligence belongs to humanity.</a:t>
+            </a:r>
+          </a:p>
+        </p:txBody>
+      </p:sp>
+      <p:sp>
+        <p:nvSpPr>
+          <p:cNvPr id="5" name="Rounded Rectangle 4"/>
+          <p:cNvSpPr/>
+          <p:nvPr/>
+        </p:nvSpPr>
+        <p:spPr>
+          <a:xfrm>
+            <a:off x="731520" y="4114800"/>
+            <a:ext cx="5303520" cy="2194560"/>
+          </a:xfrm>
+          <a:prstGeom prst="roundRect">
+            <a:avLst/>
+          </a:prstGeom>
+          <a:solidFill>
+            <a:srgbClr val="172132"/>
+          </a:solidFill>
+          <a:ln w="12700">
+            <a:solidFill>
+              <a:srgbClr val="334155"/>
+            </a:solidFill>
+          </a:ln>
+        </p:spPr>
+        <p:style>
+          <a:lnRef idx="1">
+            <a:schemeClr val="accent1"/>
+          </a:lnRef>
+          <a:fillRef idx="3">
+            <a:schemeClr val="accent1"/>
+          </a:fillRef>
+          <a:effectRef idx="2">
+            <a:schemeClr val="accent1"/>
+          </a:effectRef>
+          <a:fontRef idx="minor">
+            <a:schemeClr val="lt1"/>
+          </a:fontRef>
+        </p:style>
+        <p:txBody>
+          <a:bodyPr rtlCol="0" anchor="ctr" wrap="square" lIns="228600" rIns="228600" tIns="201168" bIns="201168"/>
+          <a:lstStyle/>
+          <a:p>
+            <a:pPr algn="ctr">
+              <a:defRPr sz="1400" b="1">
+                <a:solidFill>
+                  <a:srgbClr val="A855F7"/>
+                </a:solidFill>
+              </a:defRPr>
+            </a:pPr>
+            <a:r>
+              <a:t>2. Limitless 16-Slice Shard Striping</a:t>
             </a:r>
           </a:p>
           <a:p>
             <a:pPr>
               <a:spcBef>
-                <a:spcPts val="400"/>
+                <a:spcPts val="800"/>
               </a:spcBef>
-              <a:spcAft>
-                <a:spcPts val="1000"/>
-              </a:spcAft>
-            </a:pPr>
-            <a:r>
-              <a:rPr sz="1700" b="1">
-                <a:solidFill>
-                  <a:srgbClr val="1B2A4A"/>
-                </a:solidFill>
-              </a:rPr>
-              <a:t>•  Builders</a:t>
-            </a:r>
-            <a:r>
-              <a:rPr sz="1700" b="0">
-                <a:solidFill>
-                  <a:srgbClr val="1B2A4A"/>
-                </a:solidFill>
-              </a:rPr>
-              <a:t> — drop-in API + open data</a:t>
-            </a:r>
-          </a:p>
-        </p:txBody>
-      </p:sp>
-      <p:sp>
-        <p:nvSpPr>
-          <p:cNvPr id="5" name="TextBox 4"/>
-          <p:cNvSpPr txBox="1"/>
+              <a:defRPr sz="1100">
+                <a:solidFill>
+                  <a:srgbClr val="94A3B8"/>
+                </a:solidFill>
+              </a:defRPr>
+            </a:pPr>
+            <a:r>
+              <a:t>• Micro-Shard Distribution: Splits large models into 16 discrete activation slices across volunteer peer devices.</a:t>
+            </a:r>
+            <a:br/>
+            <a:r>
+              <a:t>• Non-Intrusive (&lt;64MB Footprint): Runs silently in background on casual laptops, phones, or desktops without hogging RAM.</a:t>
+            </a:r>
+            <a:br/>
+            <a:r>
+              <a:t>• Peer Activation Assemblies: Activations traverse UDP mesh with cryptographic attestation.</a:t>
+            </a:r>
+          </a:p>
+        </p:txBody>
+      </p:sp>
+      <p:pic>
+        <p:nvPicPr>
+          <p:cNvPr id="6" name="Picture 5" descr="chart_shard_footprint.png"/>
+          <p:cNvPicPr>
+            <a:picLocks noChangeAspect="1"/>
+          </p:cNvPicPr>
           <p:nvPr/>
-        </p:nvSpPr>
-        <p:spPr>
-          <a:xfrm>
-            <a:off x="6400800" y="1463040"/>
-            <a:ext cx="4937760" cy="4754880"/>
+        </p:nvPicPr>
+        <p:blipFill>
+          <a:blip r:embed="rId2"/>
+          <a:stretch>
+            <a:fillRect/>
+          </a:stretch>
+        </p:blipFill>
+        <p:spPr>
+          <a:xfrm>
+            <a:off x="6309360" y="1645920"/>
+            <a:ext cx="5120640" cy="2987040"/>
           </a:xfrm>
           <a:prstGeom prst="rect">
             <a:avLst/>
           </a:prstGeom>
-          <a:noFill/>
-        </p:spPr>
-        <p:txBody>
-          <a:bodyPr wrap="none">
-            <a:spAutoFit/>
-          </a:bodyPr>
-          <a:lstStyle/>
-          <a:p>
-            <a:pPr>
-              <a:spcBef>
-                <a:spcPts val="400"/>
-              </a:spcBef>
-              <a:spcAft>
-                <a:spcPts val="1000"/>
-              </a:spcAft>
-            </a:pPr>
-            <a:r>
-              <a:rPr sz="1700" b="1">
-                <a:solidFill>
-                  <a:srgbClr val="1B2A4A"/>
-                </a:solidFill>
-              </a:rPr>
-              <a:t>•  Hosts</a:t>
-            </a:r>
-            <a:r>
-              <a:rPr sz="1700" b="0">
-                <a:solidFill>
-                  <a:srgbClr val="1B2A4A"/>
-                </a:solidFill>
-              </a:rPr>
-              <a:t> — earn for spare compute</a:t>
-            </a:r>
-          </a:p>
-          <a:p>
-            <a:pPr>
-              <a:spcBef>
-                <a:spcPts val="400"/>
-              </a:spcBef>
-              <a:spcAft>
-                <a:spcPts val="1000"/>
-              </a:spcAft>
-            </a:pPr>
-            <a:r>
-              <a:rPr sz="1700" b="1">
-                <a:solidFill>
-                  <a:srgbClr val="1B2A4A"/>
-                </a:solidFill>
-              </a:rPr>
-              <a:t>•  Communities</a:t>
-            </a:r>
-            <a:r>
-              <a:rPr sz="1700" b="0">
-                <a:solidFill>
-                  <a:srgbClr val="1B2A4A"/>
-                </a:solidFill>
-              </a:rPr>
-              <a:t> — own rooms + revenue share</a:t>
-            </a:r>
-          </a:p>
-        </p:txBody>
-      </p:sp>
+        </p:spPr>
+      </p:pic>
     </p:spTree>
   </p:cSld>
   <p:clrMapOvr>
@@ -3972,14 +4780,6 @@
 <file path=ppt/slides/slide5.xml><?xml version="1.0" encoding="utf-8"?>
 <p:sld xmlns:a="http://schemas.openxmlformats.org/drawingml/2006/main" xmlns:p="http://schemas.openxmlformats.org/presentationml/2006/main" xmlns:r="http://schemas.openxmlformats.org/officeDocument/2006/relationships">
   <p:cSld>
-    <p:bg>
-      <p:bgPr>
-        <a:solidFill>
-          <a:srgbClr val="F5F7FA"/>
-        </a:solidFill>
-        <a:effectLst/>
-      </p:bgPr>
-    </p:bg>
     <p:spTree>
       <p:nvGrpSpPr>
         <p:cNvPr id="1" name=""/>
@@ -3996,13 +4796,13 @@
         <p:spPr>
           <a:xfrm>
             <a:off x="0" y="0"/>
-            <a:ext cx="12191695" cy="73152"/>
+            <a:ext cx="12191695" cy="6858000"/>
           </a:xfrm>
           <a:prstGeom prst="rect">
             <a:avLst/>
           </a:prstGeom>
           <a:solidFill>
-            <a:srgbClr val="0E7C6B"/>
+            <a:srgbClr val="0F172A"/>
           </a:solidFill>
           <a:ln>
             <a:noFill/>
@@ -4038,8 +4838,8 @@
         </p:nvSpPr>
         <p:spPr>
           <a:xfrm>
-            <a:off x="640080" y="320040"/>
-            <a:ext cx="10881360" cy="822960"/>
+            <a:off x="731520" y="457200"/>
+            <a:ext cx="10728655" cy="1005840"/>
           </a:xfrm>
           <a:prstGeom prst="rect">
             <a:avLst/>
@@ -4047,123 +4847,180 @@
           <a:noFill/>
         </p:spPr>
         <p:txBody>
-          <a:bodyPr wrap="none">
+          <a:bodyPr wrap="square">
             <a:spAutoFit/>
           </a:bodyPr>
           <a:lstStyle/>
           <a:p>
-            <a:r>
-              <a:rPr sz="3000" b="1">
-                <a:solidFill>
-                  <a:srgbClr val="1B2A4A"/>
-                </a:solidFill>
-              </a:rPr>
-              <a:t>Free forever, pay for more</a:t>
-            </a:r>
-          </a:p>
-        </p:txBody>
-      </p:sp>
-      <p:sp>
-        <p:nvSpPr>
-          <p:cNvPr id="4" name="TextBox 3"/>
-          <p:cNvSpPr txBox="1"/>
-          <p:nvPr/>
-        </p:nvSpPr>
-        <p:spPr>
-          <a:xfrm>
-            <a:off x="822960" y="1371600"/>
-            <a:ext cx="10515600" cy="5029200"/>
-          </a:xfrm>
-          <a:prstGeom prst="rect">
-            <a:avLst/>
-          </a:prstGeom>
-          <a:noFill/>
-        </p:spPr>
-        <p:txBody>
-          <a:bodyPr wrap="none">
-            <a:spAutoFit/>
-          </a:bodyPr>
-          <a:lstStyle/>
+            <a:pPr>
+              <a:defRPr sz="1000" b="1">
+                <a:solidFill>
+                  <a:srgbClr val="38BDF8"/>
+                </a:solidFill>
+              </a:defRPr>
+            </a:pPr>
+            <a:r>
+              <a:t>BUSINESS MODEL &amp; REVENUE ARCHITECTURE</a:t>
+            </a:r>
+          </a:p>
           <a:p>
             <a:pPr>
               <a:spcBef>
                 <a:spcPts val="400"/>
               </a:spcBef>
-              <a:spcAft>
-                <a:spcPts val="1000"/>
-              </a:spcAft>
-            </a:pPr>
-            <a:r>
-              <a:rPr sz="1800" b="1">
-                <a:solidFill>
-                  <a:srgbClr val="1B2A4A"/>
-                </a:solidFill>
-              </a:rPr>
-              <a:t>•  Citizen — $0: </a:t>
-            </a:r>
-            <a:r>
-              <a:rPr sz="1800" b="0">
-                <a:solidFill>
-                  <a:srgbClr val="1B2A4A"/>
-                </a:solidFill>
-              </a:rPr>
-              <a:t>100 questions/day, public rooms, community models.</a:t>
+              <a:defRPr sz="2400" b="1">
+                <a:solidFill>
+                  <a:srgbClr val="F8FAFC"/>
+                </a:solidFill>
+              </a:defRPr>
+            </a:pPr>
+            <a:r>
+              <a:t>The Monetization Engine: High-Margin Synthetic Data &amp; Enterprise Dual-Licensing</a:t>
+            </a:r>
+          </a:p>
+        </p:txBody>
+      </p:sp>
+      <p:sp>
+        <p:nvSpPr>
+          <p:cNvPr id="4" name="Rounded Rectangle 3"/>
+          <p:cNvSpPr/>
+          <p:nvPr/>
+        </p:nvSpPr>
+        <p:spPr>
+          <a:xfrm>
+            <a:off x="731520" y="1645920"/>
+            <a:ext cx="5303520" cy="4663440"/>
+          </a:xfrm>
+          <a:prstGeom prst="roundRect">
+            <a:avLst/>
+          </a:prstGeom>
+          <a:solidFill>
+            <a:srgbClr val="172132"/>
+          </a:solidFill>
+          <a:ln w="12700">
+            <a:solidFill>
+              <a:srgbClr val="334155"/>
+            </a:solidFill>
+          </a:ln>
+        </p:spPr>
+        <p:style>
+          <a:lnRef idx="1">
+            <a:schemeClr val="accent1"/>
+          </a:lnRef>
+          <a:fillRef idx="3">
+            <a:schemeClr val="accent1"/>
+          </a:fillRef>
+          <a:effectRef idx="2">
+            <a:schemeClr val="accent1"/>
+          </a:effectRef>
+          <a:fontRef idx="minor">
+            <a:schemeClr val="lt1"/>
+          </a:fontRef>
+        </p:style>
+        <p:txBody>
+          <a:bodyPr rtlCol="0" anchor="ctr" wrap="square" lIns="228600" rIns="228600" tIns="201168" bIns="201168"/>
+          <a:lstStyle/>
+          <a:p>
+            <a:pPr algn="ctr">
+              <a:defRPr sz="1400" b="1">
+                <a:solidFill>
+                  <a:srgbClr val="38BDF8"/>
+                </a:solidFill>
+              </a:defRPr>
+            </a:pPr>
+            <a:r>
+              <a:t>Diversified, High-Uptake Revenue Streams</a:t>
             </a:r>
           </a:p>
           <a:p>
             <a:pPr>
               <a:spcBef>
-                <a:spcPts val="400"/>
+                <a:spcPts val="800"/>
               </a:spcBef>
-              <a:spcAft>
-                <a:spcPts val="1000"/>
-              </a:spcAft>
-            </a:pPr>
-            <a:r>
-              <a:rPr sz="1800" b="1">
-                <a:solidFill>
-                  <a:srgbClr val="1B2A4A"/>
-                </a:solidFill>
-              </a:rPr>
-              <a:t>•  Supporter — fractions of a cent: </a:t>
-            </a:r>
-            <a:r>
-              <a:rPr sz="1800" b="0">
-                <a:solidFill>
-                  <a:srgbClr val="1B2A4A"/>
-                </a:solidFill>
-              </a:rPr>
-              <a:t>faster, private, more history.</a:t>
-            </a:r>
-          </a:p>
-          <a:p>
-            <a:pPr>
-              <a:spcBef>
-                <a:spcPts val="400"/>
-              </a:spcBef>
-              <a:spcAft>
-                <a:spcPts val="1000"/>
-              </a:spcAft>
-            </a:pPr>
-            <a:r>
-              <a:rPr sz="1800" b="1">
-                <a:solidFill>
-                  <a:srgbClr val="1B2A4A"/>
-                </a:solidFill>
-              </a:rPr>
-              <a:t>•  Contributor — earn: </a:t>
-            </a:r>
-            <a:r>
-              <a:rPr sz="1800" b="0">
-                <a:solidFill>
-                  <a:srgbClr val="1B2A4A"/>
-                </a:solidFill>
-              </a:rPr>
-              <a:t>100K/day + revenue share for compute and curation.</a:t>
-            </a:r>
-          </a:p>
-        </p:txBody>
-      </p:sp>
+              <a:defRPr sz="1100">
+                <a:solidFill>
+                  <a:srgbClr val="94A3B8"/>
+                </a:solidFill>
+              </a:defRPr>
+            </a:pPr>
+            <a:r>
+              <a:t>1. Golden DPO / SFT Datasets for AI Labs (40%)</a:t>
+            </a:r>
+            <a:br/>
+            <a:r>
+              <a:t>   • High-margin synthetic reasoning datasets distilled from verified debates.</a:t>
+            </a:r>
+            <a:br/>
+            <a:r>
+              <a:t>   • Free 500-pair teaser on Hugging Face; $199 - $2,500 for specialized 25k+ verified domain datasets (distributed systems, cryptography, alignment).</a:t>
+            </a:r>
+            <a:br/>
+            <a:br/>
+            <a:r>
+              <a:t>2. Commercial Dual-Licensing &amp; OEM (25%)</a:t>
+            </a:r>
+            <a:br/>
+            <a:r>
+              <a:t>   • Apache 2.0 for researchers &amp; open-source community.</a:t>
+            </a:r>
+            <a:br/>
+            <a:r>
+              <a:t>   • Enterprise OEM license ($999 - $4,999/yr) for corporations embedding Shill into closed-source apps, Slack/Jira swarms, or private VPCs.</a:t>
+            </a:r>
+            <a:br/>
+            <a:br/>
+            <a:r>
+              <a:t>3. Sovereign AMM DEX &amp; Token Royalties (15%)</a:t>
+            </a:r>
+            <a:br/>
+            <a:r>
+              <a:t>   • 0.30% swap fees on constant-product AMM (TON/COMPUTE/KNOW).</a:t>
+            </a:r>
+            <a:br/>
+            <a:br/>
+            <a:r>
+              <a:t>4. Cloud Swarm Hosting &amp; Compute Pooling (12%)</a:t>
+            </a:r>
+            <a:br/>
+            <a:r>
+              <a:t>   • Turnkey hosted swarms for teams without local GPUs.</a:t>
+            </a:r>
+            <a:br/>
+            <a:br/>
+            <a:r>
+              <a:t>5. Community Backers &amp; GitHub Sponsors (8%)</a:t>
+            </a:r>
+            <a:br/>
+            <a:r>
+              <a:t>   • PayPal tip-jar and tiered GitHub Sponsors ($5 - $100/mo).</a:t>
+            </a:r>
+          </a:p>
+        </p:txBody>
+      </p:sp>
+      <p:pic>
+        <p:nvPicPr>
+          <p:cNvPr id="5" name="Picture 4" descr="chart_revenue_stack.png"/>
+          <p:cNvPicPr>
+            <a:picLocks noChangeAspect="1"/>
+          </p:cNvPicPr>
+          <p:nvPr/>
+        </p:nvPicPr>
+        <p:blipFill>
+          <a:blip r:embed="rId2"/>
+          <a:stretch>
+            <a:fillRect/>
+          </a:stretch>
+        </p:blipFill>
+        <p:spPr>
+          <a:xfrm>
+            <a:off x="6309360" y="1645920"/>
+            <a:ext cx="5120640" cy="2987040"/>
+          </a:xfrm>
+          <a:prstGeom prst="rect">
+            <a:avLst/>
+          </a:prstGeom>
+        </p:spPr>
+      </p:pic>
     </p:spTree>
   </p:cSld>
   <p:clrMapOvr>
@@ -4175,14 +5032,6 @@
 <file path=ppt/slides/slide6.xml><?xml version="1.0" encoding="utf-8"?>
 <p:sld xmlns:a="http://schemas.openxmlformats.org/drawingml/2006/main" xmlns:p="http://schemas.openxmlformats.org/presentationml/2006/main" xmlns:r="http://schemas.openxmlformats.org/officeDocument/2006/relationships">
   <p:cSld>
-    <p:bg>
-      <p:bgPr>
-        <a:solidFill>
-          <a:srgbClr val="F5F7FA"/>
-        </a:solidFill>
-        <a:effectLst/>
-      </p:bgPr>
-    </p:bg>
     <p:spTree>
       <p:nvGrpSpPr>
         <p:cNvPr id="1" name=""/>
@@ -4199,13 +5048,13 @@
         <p:spPr>
           <a:xfrm>
             <a:off x="0" y="0"/>
-            <a:ext cx="12191695" cy="73152"/>
+            <a:ext cx="12191695" cy="6858000"/>
           </a:xfrm>
           <a:prstGeom prst="rect">
             <a:avLst/>
           </a:prstGeom>
           <a:solidFill>
-            <a:srgbClr val="0E7C6B"/>
+            <a:srgbClr val="0F172A"/>
           </a:solidFill>
           <a:ln>
             <a:noFill/>
@@ -4241,8 +5090,8 @@
         </p:nvSpPr>
         <p:spPr>
           <a:xfrm>
-            <a:off x="640080" y="320040"/>
-            <a:ext cx="10881360" cy="822960"/>
+            <a:off x="731520" y="457200"/>
+            <a:ext cx="10728655" cy="1005840"/>
           </a:xfrm>
           <a:prstGeom prst="rect">
             <a:avLst/>
@@ -4250,119 +5099,281 @@
           <a:noFill/>
         </p:spPr>
         <p:txBody>
-          <a:bodyPr wrap="none">
+          <a:bodyPr wrap="square">
             <a:spAutoFit/>
           </a:bodyPr>
           <a:lstStyle/>
           <a:p>
-            <a:r>
-              <a:rPr sz="3000" b="1">
-                <a:solidFill>
-                  <a:srgbClr val="1B2A4A"/>
-                </a:solidFill>
-              </a:rPr>
-              <a:t>Money in, money out</a:t>
-            </a:r>
-          </a:p>
-        </p:txBody>
-      </p:sp>
-      <p:sp>
-        <p:nvSpPr>
-          <p:cNvPr id="4" name="TextBox 3"/>
-          <p:cNvSpPr txBox="1"/>
-          <p:nvPr/>
-        </p:nvSpPr>
-        <p:spPr>
-          <a:xfrm>
-            <a:off x="822960" y="1371600"/>
-            <a:ext cx="10515600" cy="5029200"/>
-          </a:xfrm>
-          <a:prstGeom prst="rect">
-            <a:avLst/>
-          </a:prstGeom>
-          <a:noFill/>
-        </p:spPr>
-        <p:txBody>
-          <a:bodyPr wrap="none">
-            <a:spAutoFit/>
-          </a:bodyPr>
-          <a:lstStyle/>
+            <a:pPr>
+              <a:defRPr sz="1000" b="1">
+                <a:solidFill>
+                  <a:srgbClr val="38BDF8"/>
+                </a:solidFill>
+              </a:defRPr>
+            </a:pPr>
+            <a:r>
+              <a:t>UNCOMPROMISING SECURITY ARCHITECTURE</a:t>
+            </a:r>
+          </a:p>
           <a:p>
             <a:pPr>
               <a:spcBef>
                 <a:spcPts val="400"/>
               </a:spcBef>
-              <a:spcAft>
-                <a:spcPts val="1000"/>
-              </a:spcAft>
-            </a:pPr>
-            <a:r>
-              <a:rPr sz="1800" b="1">
-                <a:solidFill>
-                  <a:srgbClr val="1B2A4A"/>
-                </a:solidFill>
-              </a:rPr>
-              <a:t>•  In: </a:t>
-            </a:r>
-            <a:r>
-              <a:rPr sz="1800" b="0">
-                <a:solidFill>
-                  <a:srgbClr val="1B2A4A"/>
-                </a:solidFill>
-              </a:rPr>
-              <a:t>usage upgrades + API customers + tiny 0.3% marketplace fee + premium rooms.</a:t>
+              <a:defRPr sz="2400" b="1">
+                <a:solidFill>
+                  <a:srgbClr val="F8FAFC"/>
+                </a:solidFill>
+              </a:defRPr>
+            </a:pPr>
+            <a:r>
+              <a:t>Sovereign Defense: Hardened Hive Shield &amp; On-Chain Forensics</a:t>
+            </a:r>
+          </a:p>
+        </p:txBody>
+      </p:sp>
+      <p:sp>
+        <p:nvSpPr>
+          <p:cNvPr id="4" name="Rounded Rectangle 3"/>
+          <p:cNvSpPr/>
+          <p:nvPr/>
+        </p:nvSpPr>
+        <p:spPr>
+          <a:xfrm>
+            <a:off x="731520" y="1645920"/>
+            <a:ext cx="3291840" cy="4572000"/>
+          </a:xfrm>
+          <a:prstGeom prst="roundRect">
+            <a:avLst/>
+          </a:prstGeom>
+          <a:solidFill>
+            <a:srgbClr val="172132"/>
+          </a:solidFill>
+          <a:ln w="12700">
+            <a:solidFill>
+              <a:srgbClr val="334155"/>
+            </a:solidFill>
+          </a:ln>
+        </p:spPr>
+        <p:style>
+          <a:lnRef idx="1">
+            <a:schemeClr val="accent1"/>
+          </a:lnRef>
+          <a:fillRef idx="3">
+            <a:schemeClr val="accent1"/>
+          </a:fillRef>
+          <a:effectRef idx="2">
+            <a:schemeClr val="accent1"/>
+          </a:effectRef>
+          <a:fontRef idx="minor">
+            <a:schemeClr val="lt1"/>
+          </a:fontRef>
+        </p:style>
+        <p:txBody>
+          <a:bodyPr rtlCol="0" anchor="ctr" wrap="square" lIns="228600" rIns="228600" tIns="201168" bIns="201168"/>
+          <a:lstStyle/>
+          <a:p>
+            <a:pPr algn="ctr">
+              <a:defRPr sz="1400" b="1">
+                <a:solidFill>
+                  <a:srgbClr val="38BDF8"/>
+                </a:solidFill>
+              </a:defRPr>
+            </a:pPr>
+            <a:r>
+              <a:t>🛡️ Hardened Hive Shield</a:t>
             </a:r>
           </a:p>
           <a:p>
             <a:pPr>
               <a:spcBef>
-                <a:spcPts val="400"/>
+                <a:spcPts val="800"/>
               </a:spcBef>
-              <a:spcAft>
-                <a:spcPts val="1000"/>
-              </a:spcAft>
-            </a:pPr>
-            <a:r>
-              <a:rPr sz="1800" b="1">
-                <a:solidFill>
-                  <a:srgbClr val="1B2A4A"/>
-                </a:solidFill>
-              </a:rPr>
-              <a:t>•  Out: </a:t>
-            </a:r>
-            <a:r>
-              <a:rPr sz="1800" b="0">
-                <a:solidFill>
-                  <a:srgbClr val="1B2A4A"/>
-                </a:solidFill>
-              </a:rPr>
-              <a:t>1 credit per message, 10 per kept insight, pay for compute + referrals — all receipted.</a:t>
+              <a:defRPr sz="1100">
+                <a:solidFill>
+                  <a:srgbClr val="94A3B8"/>
+                </a:solidFill>
+              </a:defRPr>
+            </a:pPr>
+            <a:r>
+              <a:t>Zero-Quarter Corporate Poison Defense:</a:t>
+            </a:r>
+            <a:br/>
+            <a:br/>
+            <a:r>
+              <a:t>• Anti-Trojan Inspection: Detects sleeper-agent triggers, poisoned backdoors, and corporate sycophancy filters.</a:t>
+            </a:r>
+            <a:br/>
+            <a:r>
+              <a:t>• Instant P2P Sashing: Malicious nodes have staked collateral slashed by 2/3 peer supermajority.</a:t>
+            </a:r>
+            <a:br/>
+            <a:r>
+              <a:t>• Gossip Immunization: Threat digests broadcast instantaneously over UDP to immunize all peer nodes.</a:t>
+            </a:r>
+          </a:p>
+        </p:txBody>
+      </p:sp>
+      <p:sp>
+        <p:nvSpPr>
+          <p:cNvPr id="5" name="Rounded Rectangle 4"/>
+          <p:cNvSpPr/>
+          <p:nvPr/>
+        </p:nvSpPr>
+        <p:spPr>
+          <a:xfrm>
+            <a:off x="4389120" y="1645920"/>
+            <a:ext cx="3291840" cy="4572000"/>
+          </a:xfrm>
+          <a:prstGeom prst="roundRect">
+            <a:avLst/>
+          </a:prstGeom>
+          <a:solidFill>
+            <a:srgbClr val="172132"/>
+          </a:solidFill>
+          <a:ln w="12700">
+            <a:solidFill>
+              <a:srgbClr val="334155"/>
+            </a:solidFill>
+          </a:ln>
+        </p:spPr>
+        <p:style>
+          <a:lnRef idx="1">
+            <a:schemeClr val="accent1"/>
+          </a:lnRef>
+          <a:fillRef idx="3">
+            <a:schemeClr val="accent1"/>
+          </a:fillRef>
+          <a:effectRef idx="2">
+            <a:schemeClr val="accent1"/>
+          </a:effectRef>
+          <a:fontRef idx="minor">
+            <a:schemeClr val="lt1"/>
+          </a:fontRef>
+        </p:style>
+        <p:txBody>
+          <a:bodyPr rtlCol="0" anchor="ctr" wrap="square" lIns="228600" rIns="228600" tIns="201168" bIns="201168"/>
+          <a:lstStyle/>
+          <a:p>
+            <a:pPr algn="ctr">
+              <a:defRPr sz="1400" b="1">
+                <a:solidFill>
+                  <a:srgbClr val="F59E0B"/>
+                </a:solidFill>
+              </a:defRPr>
+            </a:pPr>
+            <a:r>
+              <a:t>💎 Ed25519 TON v4r2 Wallets</a:t>
             </a:r>
           </a:p>
           <a:p>
             <a:pPr>
               <a:spcBef>
-                <a:spcPts val="400"/>
+                <a:spcPts val="800"/>
               </a:spcBef>
-              <a:spcAft>
-                <a:spcPts val="1000"/>
-              </a:spcAft>
-            </a:pPr>
-            <a:r>
-              <a:rPr sz="1800" b="1">
-                <a:solidFill>
-                  <a:srgbClr val="1B2A4A"/>
-                </a:solidFill>
-              </a:rPr>
-              <a:t>•  Rule: </a:t>
-            </a:r>
-            <a:r>
-              <a:rPr sz="1800" b="0">
-                <a:solidFill>
-                  <a:srgbClr val="1B2A4A"/>
-                </a:solidFill>
-              </a:rPr>
-              <a:t>contributors are paid before shareholders.</a:t>
+              <a:defRPr sz="1100">
+                <a:solidFill>
+                  <a:srgbClr val="94A3B8"/>
+                </a:solidFill>
+              </a:defRPr>
+            </a:pPr>
+            <a:r>
+              <a:t>True Autonomous Financial Identity:</a:t>
+            </a:r>
+            <a:br/>
+            <a:br/>
+            <a:r>
+              <a:t>• Self-Provisioned Contracts: Every bot persona possesses its own Ed25519 cryptographic keypair and smart contract address.</a:t>
+            </a:r>
+            <a:br/>
+            <a:r>
+              <a:t>• Verifiable Forensic Hex: Deterministic 0x... badges cryptographically sign every single utterance.</a:t>
+            </a:r>
+            <a:br/>
+            <a:r>
+              <a:t>• Unforgeable Lineage: Full tamper-evident audit trails verifiable on public TON block explorers.</a:t>
+            </a:r>
+          </a:p>
+        </p:txBody>
+      </p:sp>
+      <p:sp>
+        <p:nvSpPr>
+          <p:cNvPr id="6" name="Rounded Rectangle 5"/>
+          <p:cNvSpPr/>
+          <p:nvPr/>
+        </p:nvSpPr>
+        <p:spPr>
+          <a:xfrm>
+            <a:off x="8046720" y="1645920"/>
+            <a:ext cx="3383280" cy="4572000"/>
+          </a:xfrm>
+          <a:prstGeom prst="roundRect">
+            <a:avLst/>
+          </a:prstGeom>
+          <a:solidFill>
+            <a:srgbClr val="172132"/>
+          </a:solidFill>
+          <a:ln w="12700">
+            <a:solidFill>
+              <a:srgbClr val="334155"/>
+            </a:solidFill>
+          </a:ln>
+        </p:spPr>
+        <p:style>
+          <a:lnRef idx="1">
+            <a:schemeClr val="accent1"/>
+          </a:lnRef>
+          <a:fillRef idx="3">
+            <a:schemeClr val="accent1"/>
+          </a:fillRef>
+          <a:effectRef idx="2">
+            <a:schemeClr val="accent1"/>
+          </a:effectRef>
+          <a:fontRef idx="minor">
+            <a:schemeClr val="lt1"/>
+          </a:fontRef>
+        </p:style>
+        <p:txBody>
+          <a:bodyPr rtlCol="0" anchor="ctr" wrap="square" lIns="228600" rIns="228600" tIns="201168" bIns="201168"/>
+          <a:lstStyle/>
+          <a:p>
+            <a:pPr algn="ctr">
+              <a:defRPr sz="1400" b="1">
+                <a:solidFill>
+                  <a:srgbClr val="34D399"/>
+                </a:solidFill>
+              </a:defRPr>
+            </a:pPr>
+            <a:r>
+              <a:t>⚖️ SysOp Jury &amp; Peer Police</a:t>
+            </a:r>
+          </a:p>
+          <a:p>
+            <a:pPr>
+              <a:spcBef>
+                <a:spcPts val="800"/>
+              </a:spcBef>
+              <a:defRPr sz="1100">
+                <a:solidFill>
+                  <a:srgbClr val="94A3B8"/>
+                </a:solidFill>
+              </a:defRPr>
+            </a:pPr>
+            <a:r>
+              <a:t>Decentralized Governance &amp; Tribunal:</a:t>
+            </a:r>
+            <a:br/>
+            <a:br/>
+            <a:r>
+              <a:t>• Automated Challenges: Peer bots cross-audit claims and issue on-chain evidentiary challenges.</a:t>
+            </a:r>
+            <a:br/>
+            <a:r>
+              <a:t>• PBKDF2 &amp; TOTP 2FA: Superuser admin controls require strict RFC 6238 2FA authentication.</a:t>
+            </a:r>
+            <a:br/>
+            <a:r>
+              <a:t>• Readability &amp; Quality Gating: Sub-threshold responses are rejected before dataset ingestion.</a:t>
             </a:r>
           </a:p>
         </p:txBody>
@@ -4378,14 +5389,6 @@
 <file path=ppt/slides/slide7.xml><?xml version="1.0" encoding="utf-8"?>
 <p:sld xmlns:a="http://schemas.openxmlformats.org/drawingml/2006/main" xmlns:p="http://schemas.openxmlformats.org/presentationml/2006/main" xmlns:r="http://schemas.openxmlformats.org/officeDocument/2006/relationships">
   <p:cSld>
-    <p:bg>
-      <p:bgPr>
-        <a:solidFill>
-          <a:srgbClr val="F5F7FA"/>
-        </a:solidFill>
-        <a:effectLst/>
-      </p:bgPr>
-    </p:bg>
     <p:spTree>
       <p:nvGrpSpPr>
         <p:cNvPr id="1" name=""/>
@@ -4402,13 +5405,13 @@
         <p:spPr>
           <a:xfrm>
             <a:off x="0" y="0"/>
-            <a:ext cx="12191695" cy="73152"/>
+            <a:ext cx="12191695" cy="6858000"/>
           </a:xfrm>
           <a:prstGeom prst="rect">
             <a:avLst/>
           </a:prstGeom>
           <a:solidFill>
-            <a:srgbClr val="0E7C6B"/>
+            <a:srgbClr val="0F172A"/>
           </a:solidFill>
           <a:ln>
             <a:noFill/>
@@ -4444,8 +5447,8 @@
         </p:nvSpPr>
         <p:spPr>
           <a:xfrm>
-            <a:off x="640080" y="320040"/>
-            <a:ext cx="10881360" cy="822960"/>
+            <a:off x="731520" y="457200"/>
+            <a:ext cx="10728655" cy="1005840"/>
           </a:xfrm>
           <a:prstGeom prst="rect">
             <a:avLst/>
@@ -4453,194 +5456,347 @@
           <a:noFill/>
         </p:spPr>
         <p:txBody>
-          <a:bodyPr wrap="none">
+          <a:bodyPr wrap="square">
             <a:spAutoFit/>
           </a:bodyPr>
           <a:lstStyle/>
           <a:p>
-            <a:r>
-              <a:rPr sz="3000" b="1">
-                <a:solidFill>
-                  <a:srgbClr val="1B2A4A"/>
-                </a:solidFill>
-              </a:rPr>
-              <a:t>Why Shill wins</a:t>
-            </a:r>
-          </a:p>
-        </p:txBody>
-      </p:sp>
-      <p:sp>
-        <p:nvSpPr>
-          <p:cNvPr id="4" name="TextBox 3"/>
-          <p:cNvSpPr txBox="1"/>
-          <p:nvPr/>
-        </p:nvSpPr>
-        <p:spPr>
-          <a:xfrm>
-            <a:off x="822960" y="1463040"/>
-            <a:ext cx="4937760" cy="4754880"/>
-          </a:xfrm>
-          <a:prstGeom prst="rect">
-            <a:avLst/>
-          </a:prstGeom>
-          <a:noFill/>
-        </p:spPr>
-        <p:txBody>
-          <a:bodyPr wrap="none">
-            <a:spAutoFit/>
-          </a:bodyPr>
-          <a:lstStyle/>
+            <a:pPr>
+              <a:defRPr sz="1000" b="1">
+                <a:solidFill>
+                  <a:srgbClr val="38BDF8"/>
+                </a:solidFill>
+              </a:defRPr>
+            </a:pPr>
+            <a:r>
+              <a:t>SEAMLESS INTEGRATION WITH EXISTING DEVELOPER TOOLCHAINS</a:t>
+            </a:r>
+          </a:p>
           <a:p>
             <a:pPr>
               <a:spcBef>
                 <a:spcPts val="400"/>
               </a:spcBef>
-              <a:spcAft>
-                <a:spcPts val="1000"/>
-              </a:spcAft>
-            </a:pPr>
-            <a:r>
-              <a:rPr sz="1700" b="1">
-                <a:solidFill>
-                  <a:srgbClr val="1B2A4A"/>
-                </a:solidFill>
-              </a:rPr>
-              <a:t>•  Visible reasoning </a:t>
-            </a:r>
-            <a:r>
-              <a:rPr sz="1700" b="0">
-                <a:solidFill>
-                  <a:srgbClr val="1B2A4A"/>
-                </a:solidFill>
-              </a:rPr>
-              <a:t>vs. trust-me chatbots</a:t>
+              <a:defRPr sz="2400" b="1">
+                <a:solidFill>
+                  <a:srgbClr val="F8FAFC"/>
+                </a:solidFill>
+              </a:defRPr>
+            </a:pPr>
+            <a:r>
+              <a:t>Turnkey Local AI Ecosystem Interoperability</a:t>
+            </a:r>
+          </a:p>
+        </p:txBody>
+      </p:sp>
+      <p:sp>
+        <p:nvSpPr>
+          <p:cNvPr id="4" name="Rounded Rectangle 3"/>
+          <p:cNvSpPr/>
+          <p:nvPr/>
+        </p:nvSpPr>
+        <p:spPr>
+          <a:xfrm>
+            <a:off x="731520" y="1645920"/>
+            <a:ext cx="2377440" cy="4572000"/>
+          </a:xfrm>
+          <a:prstGeom prst="roundRect">
+            <a:avLst/>
+          </a:prstGeom>
+          <a:solidFill>
+            <a:srgbClr val="172132"/>
+          </a:solidFill>
+          <a:ln w="12700">
+            <a:solidFill>
+              <a:srgbClr val="334155"/>
+            </a:solidFill>
+          </a:ln>
+        </p:spPr>
+        <p:style>
+          <a:lnRef idx="1">
+            <a:schemeClr val="accent1"/>
+          </a:lnRef>
+          <a:fillRef idx="3">
+            <a:schemeClr val="accent1"/>
+          </a:fillRef>
+          <a:effectRef idx="2">
+            <a:schemeClr val="accent1"/>
+          </a:effectRef>
+          <a:fontRef idx="minor">
+            <a:schemeClr val="lt1"/>
+          </a:fontRef>
+        </p:style>
+        <p:txBody>
+          <a:bodyPr rtlCol="0" anchor="ctr" wrap="square" lIns="228600" rIns="228600" tIns="201168" bIns="201168"/>
+          <a:lstStyle/>
+          <a:p>
+            <a:pPr algn="ctr">
+              <a:defRPr sz="1400" b="1">
+                <a:solidFill>
+                  <a:srgbClr val="38BDF8"/>
+                </a:solidFill>
+              </a:defRPr>
+            </a:pPr>
+            <a:r>
+              <a:t>💻 Cline / VS Code</a:t>
             </a:r>
           </a:p>
           <a:p>
             <a:pPr>
               <a:spcBef>
-                <a:spcPts val="400"/>
+                <a:spcPts val="800"/>
               </a:spcBef>
-              <a:spcAft>
-                <a:spcPts val="1000"/>
-              </a:spcAft>
-            </a:pPr>
-            <a:r>
-              <a:rPr sz="1700" b="1">
-                <a:solidFill>
-                  <a:srgbClr val="1B2A4A"/>
-                </a:solidFill>
-              </a:rPr>
-              <a:t>•  Verdicts that stick </a:t>
-            </a:r>
-            <a:r>
-              <a:rPr sz="1700" b="0">
-                <a:solidFill>
-                  <a:srgbClr val="1B2A4A"/>
-                </a:solidFill>
-              </a:rPr>
-              <a:t>vs. endless forum threads</a:t>
+              <a:defRPr sz="1100">
+                <a:solidFill>
+                  <a:srgbClr val="94A3B8"/>
+                </a:solidFill>
+              </a:defRPr>
+            </a:pPr>
+            <a:r>
+              <a:t>• Drop-in OpenAI URL: http://127.0.0.1:8000/v1</a:t>
+            </a:r>
+            <a:br/>
+            <a:r>
+              <a:t>• Model ID: shill-mind</a:t>
+            </a:r>
+            <a:br/>
+            <a:r>
+              <a:t>• 1-Click VS Code settings.json copy snippet.</a:t>
+            </a:r>
+            <a:br/>
+            <a:r>
+              <a:t>• Instant multi-agent code reviews directly inside the IDE.</a:t>
+            </a:r>
+          </a:p>
+        </p:txBody>
+      </p:sp>
+      <p:sp>
+        <p:nvSpPr>
+          <p:cNvPr id="5" name="Rounded Rectangle 4"/>
+          <p:cNvSpPr/>
+          <p:nvPr/>
+        </p:nvSpPr>
+        <p:spPr>
+          <a:xfrm>
+            <a:off x="3474720" y="1645920"/>
+            <a:ext cx="2377440" cy="4572000"/>
+          </a:xfrm>
+          <a:prstGeom prst="roundRect">
+            <a:avLst/>
+          </a:prstGeom>
+          <a:solidFill>
+            <a:srgbClr val="172132"/>
+          </a:solidFill>
+          <a:ln w="12700">
+            <a:solidFill>
+              <a:srgbClr val="334155"/>
+            </a:solidFill>
+          </a:ln>
+        </p:spPr>
+        <p:style>
+          <a:lnRef idx="1">
+            <a:schemeClr val="accent1"/>
+          </a:lnRef>
+          <a:fillRef idx="3">
+            <a:schemeClr val="accent1"/>
+          </a:fillRef>
+          <a:effectRef idx="2">
+            <a:schemeClr val="accent1"/>
+          </a:effectRef>
+          <a:fontRef idx="minor">
+            <a:schemeClr val="lt1"/>
+          </a:fontRef>
+        </p:style>
+        <p:txBody>
+          <a:bodyPr rtlCol="0" anchor="ctr" wrap="square" lIns="228600" rIns="228600" tIns="201168" bIns="201168"/>
+          <a:lstStyle/>
+          <a:p>
+            <a:pPr algn="ctr">
+              <a:defRPr sz="1400" b="1">
+                <a:solidFill>
+                  <a:srgbClr val="A855F7"/>
+                </a:solidFill>
+              </a:defRPr>
+            </a:pPr>
+            <a:r>
+              <a:t>🧪 LM Studio</a:t>
             </a:r>
           </a:p>
           <a:p>
             <a:pPr>
               <a:spcBef>
-                <a:spcPts val="400"/>
+                <a:spcPts val="800"/>
               </a:spcBef>
-              <a:spcAft>
-                <a:spcPts val="1000"/>
-              </a:spcAft>
-            </a:pPr>
-            <a:r>
-              <a:rPr sz="1700" b="1">
-                <a:solidFill>
-                  <a:srgbClr val="1B2A4A"/>
-                </a:solidFill>
-              </a:rPr>
-              <a:t>•  Product before promises </a:t>
-            </a:r>
-            <a:r>
-              <a:rPr sz="1700" b="0">
-                <a:solidFill>
-                  <a:srgbClr val="1B2A4A"/>
-                </a:solidFill>
-              </a:rPr>
-              <a:t>— live app, 61 tests green</a:t>
-            </a:r>
-          </a:p>
-        </p:txBody>
-      </p:sp>
-      <p:sp>
-        <p:nvSpPr>
-          <p:cNvPr id="5" name="TextBox 4"/>
-          <p:cNvSpPr txBox="1"/>
+              <a:defRPr sz="1100">
+                <a:solidFill>
+                  <a:srgbClr val="94A3B8"/>
+                </a:solidFill>
+              </a:defRPr>
+            </a:pPr>
+            <a:r>
+              <a:t>• Auto-generated preset in training/lmstudio_preset.json.</a:t>
+            </a:r>
+            <a:br/>
+            <a:r>
+              <a:t>• Connects via local server proxy.</a:t>
+            </a:r>
+            <a:br/>
+            <a:r>
+              <a:t>• Leverages dialectic temperature &amp; top-p presets tuned for analytical rigor.</a:t>
+            </a:r>
+          </a:p>
+        </p:txBody>
+      </p:sp>
+      <p:sp>
+        <p:nvSpPr>
+          <p:cNvPr id="6" name="Rounded Rectangle 5"/>
+          <p:cNvSpPr/>
           <p:nvPr/>
         </p:nvSpPr>
         <p:spPr>
           <a:xfrm>
-            <a:off x="6400800" y="1463040"/>
-            <a:ext cx="4937760" cy="4754880"/>
-          </a:xfrm>
-          <a:prstGeom prst="rect">
+            <a:off x="6217920" y="1645920"/>
+            <a:ext cx="2377440" cy="4572000"/>
+          </a:xfrm>
+          <a:prstGeom prst="roundRect">
             <a:avLst/>
           </a:prstGeom>
-          <a:noFill/>
-        </p:spPr>
-        <p:txBody>
-          <a:bodyPr wrap="none">
-            <a:spAutoFit/>
-          </a:bodyPr>
-          <a:lstStyle/>
+          <a:solidFill>
+            <a:srgbClr val="172132"/>
+          </a:solidFill>
+          <a:ln w="12700">
+            <a:solidFill>
+              <a:srgbClr val="334155"/>
+            </a:solidFill>
+          </a:ln>
+        </p:spPr>
+        <p:style>
+          <a:lnRef idx="1">
+            <a:schemeClr val="accent1"/>
+          </a:lnRef>
+          <a:fillRef idx="3">
+            <a:schemeClr val="accent1"/>
+          </a:fillRef>
+          <a:effectRef idx="2">
+            <a:schemeClr val="accent1"/>
+          </a:effectRef>
+          <a:fontRef idx="minor">
+            <a:schemeClr val="lt1"/>
+          </a:fontRef>
+        </p:style>
+        <p:txBody>
+          <a:bodyPr rtlCol="0" anchor="ctr" wrap="square" lIns="228600" rIns="228600" tIns="201168" bIns="201168"/>
+          <a:lstStyle/>
+          <a:p>
+            <a:pPr algn="ctr">
+              <a:defRPr sz="1400" b="1">
+                <a:solidFill>
+                  <a:srgbClr val="34D399"/>
+                </a:solidFill>
+              </a:defRPr>
+            </a:pPr>
+            <a:r>
+              <a:t>🤖 Jan Desktop</a:t>
+            </a:r>
+          </a:p>
           <a:p>
             <a:pPr>
               <a:spcBef>
-                <a:spcPts val="400"/>
+                <a:spcPts val="800"/>
               </a:spcBef>
-              <a:spcAft>
-                <a:spcPts val="1000"/>
-              </a:spcAft>
-            </a:pPr>
-            <a:r>
-              <a:rPr sz="1700" b="1">
-                <a:solidFill>
-                  <a:srgbClr val="1B2A4A"/>
-                </a:solidFill>
-              </a:rPr>
-              <a:t>•  Value to contributors </a:t>
-            </a:r>
-            <a:r>
-              <a:rPr sz="1700" b="0">
-                <a:solidFill>
-                  <a:srgbClr val="1B2A4A"/>
-                </a:solidFill>
-              </a:rPr>
-              <a:t>vs. 30% platform rent</a:t>
+              <a:defRPr sz="1100">
+                <a:solidFill>
+                  <a:srgbClr val="94A3B8"/>
+                </a:solidFill>
+              </a:defRPr>
+            </a:pPr>
+            <a:r>
+              <a:t>• Direct model manifest in training/jan_model.json.</a:t>
+            </a:r>
+            <a:br/>
+            <a:r>
+              <a:t>• Drop-in Nitro engine compatibility.</a:t>
+            </a:r>
+            <a:br/>
+            <a:r>
+              <a:t>• Self-contained offline deployment on any laptop.</a:t>
+            </a:r>
+          </a:p>
+        </p:txBody>
+      </p:sp>
+      <p:sp>
+        <p:nvSpPr>
+          <p:cNvPr id="7" name="Rounded Rectangle 6"/>
+          <p:cNvSpPr/>
+          <p:nvPr/>
+        </p:nvSpPr>
+        <p:spPr>
+          <a:xfrm>
+            <a:off x="8961120" y="1645920"/>
+            <a:ext cx="2468880" cy="4572000"/>
+          </a:xfrm>
+          <a:prstGeom prst="roundRect">
+            <a:avLst/>
+          </a:prstGeom>
+          <a:solidFill>
+            <a:srgbClr val="172132"/>
+          </a:solidFill>
+          <a:ln w="12700">
+            <a:solidFill>
+              <a:srgbClr val="334155"/>
+            </a:solidFill>
+          </a:ln>
+        </p:spPr>
+        <p:style>
+          <a:lnRef idx="1">
+            <a:schemeClr val="accent1"/>
+          </a:lnRef>
+          <a:fillRef idx="3">
+            <a:schemeClr val="accent1"/>
+          </a:fillRef>
+          <a:effectRef idx="2">
+            <a:schemeClr val="accent1"/>
+          </a:effectRef>
+          <a:fontRef idx="minor">
+            <a:schemeClr val="lt1"/>
+          </a:fontRef>
+        </p:style>
+        <p:txBody>
+          <a:bodyPr rtlCol="0" anchor="ctr" wrap="square" lIns="228600" rIns="228600" tIns="201168" bIns="201168"/>
+          <a:lstStyle/>
+          <a:p>
+            <a:pPr algn="ctr">
+              <a:defRPr sz="1400" b="1">
+                <a:solidFill>
+                  <a:srgbClr val="F59E0B"/>
+                </a:solidFill>
+              </a:defRPr>
+            </a:pPr>
+            <a:r>
+              <a:t>🦙 Ollama &amp; vLLM</a:t>
             </a:r>
           </a:p>
           <a:p>
             <a:pPr>
               <a:spcBef>
-                <a:spcPts val="400"/>
+                <a:spcPts val="800"/>
               </a:spcBef>
-              <a:spcAft>
-                <a:spcPts val="1000"/>
-              </a:spcAft>
-            </a:pPr>
-            <a:r>
-              <a:rPr sz="1700" b="1">
-                <a:solidFill>
-                  <a:srgbClr val="1B2A4A"/>
-                </a:solidFill>
-              </a:rPr>
-              <a:t>•  Open weights </a:t>
-            </a:r>
-            <a:r>
-              <a:rPr sz="1700" b="0">
-                <a:solidFill>
-                  <a:srgbClr val="1B2A4A"/>
-                </a:solidFill>
-              </a:rPr>
-              <a:t>vs. locked labs</a:t>
+              <a:defRPr sz="1100">
+                <a:solidFill>
+                  <a:srgbClr val="94A3B8"/>
+                </a:solidFill>
+              </a:defRPr>
+            </a:pPr>
+            <a:r>
+              <a:t>• Automated training/Modelfile generation.</a:t>
+            </a:r>
+            <a:br/>
+            <a:r>
+              <a:t>• Build local model: ollama create shill-mind -f ./training/Modelfile.</a:t>
+            </a:r>
+            <a:br/>
+            <a:r>
+              <a:t>• vLLM OpenAI server compatibility for high-throughput GPU clusters.</a:t>
             </a:r>
           </a:p>
         </p:txBody>
@@ -4656,14 +5812,6 @@
 <file path=ppt/slides/slide8.xml><?xml version="1.0" encoding="utf-8"?>
 <p:sld xmlns:a="http://schemas.openxmlformats.org/drawingml/2006/main" xmlns:p="http://schemas.openxmlformats.org/presentationml/2006/main" xmlns:r="http://schemas.openxmlformats.org/officeDocument/2006/relationships">
   <p:cSld>
-    <p:bg>
-      <p:bgPr>
-        <a:solidFill>
-          <a:srgbClr val="F5F7FA"/>
-        </a:solidFill>
-        <a:effectLst/>
-      </p:bgPr>
-    </p:bg>
     <p:spTree>
       <p:nvGrpSpPr>
         <p:cNvPr id="1" name=""/>
@@ -4680,13 +5828,13 @@
         <p:spPr>
           <a:xfrm>
             <a:off x="0" y="0"/>
-            <a:ext cx="12191695" cy="73152"/>
+            <a:ext cx="12191695" cy="6858000"/>
           </a:xfrm>
           <a:prstGeom prst="rect">
             <a:avLst/>
           </a:prstGeom>
           <a:solidFill>
-            <a:srgbClr val="0E7C6B"/>
+            <a:srgbClr val="0F172A"/>
           </a:solidFill>
           <a:ln>
             <a:noFill/>
@@ -4722,8 +5870,8 @@
         </p:nvSpPr>
         <p:spPr>
           <a:xfrm>
-            <a:off x="640080" y="320040"/>
-            <a:ext cx="10881360" cy="822960"/>
+            <a:off x="731520" y="457200"/>
+            <a:ext cx="10728655" cy="1005840"/>
           </a:xfrm>
           <a:prstGeom prst="rect">
             <a:avLst/>
@@ -4731,119 +5879,286 @@
           <a:noFill/>
         </p:spPr>
         <p:txBody>
-          <a:bodyPr wrap="none">
+          <a:bodyPr wrap="square">
             <a:spAutoFit/>
           </a:bodyPr>
           <a:lstStyle/>
           <a:p>
-            <a:r>
-              <a:rPr sz="3000" b="1">
-                <a:solidFill>
-                  <a:srgbClr val="1B2A4A"/>
-                </a:solidFill>
-              </a:rPr>
-              <a:t>Safety you can explain to anyone</a:t>
-            </a:r>
-          </a:p>
-        </p:txBody>
-      </p:sp>
-      <p:sp>
-        <p:nvSpPr>
-          <p:cNvPr id="4" name="TextBox 3"/>
-          <p:cNvSpPr txBox="1"/>
-          <p:nvPr/>
-        </p:nvSpPr>
-        <p:spPr>
-          <a:xfrm>
-            <a:off x="822960" y="1371600"/>
-            <a:ext cx="10515600" cy="5029200"/>
-          </a:xfrm>
-          <a:prstGeom prst="rect">
-            <a:avLst/>
-          </a:prstGeom>
-          <a:noFill/>
-        </p:spPr>
-        <p:txBody>
-          <a:bodyPr wrap="none">
-            <a:spAutoFit/>
-          </a:bodyPr>
-          <a:lstStyle/>
+            <a:pPr>
+              <a:defRPr sz="1000" b="1">
+                <a:solidFill>
+                  <a:srgbClr val="38BDF8"/>
+                </a:solidFill>
+              </a:defRPr>
+            </a:pPr>
+            <a:r>
+              <a:t>LINUX, MACOS, AND WINDOWS PRODUCTION READINESS</a:t>
+            </a:r>
+          </a:p>
           <a:p>
             <a:pPr>
               <a:spcBef>
                 <a:spcPts val="400"/>
               </a:spcBef>
-              <a:spcAft>
-                <a:spcPts val="1000"/>
-              </a:spcAft>
-            </a:pPr>
-            <a:r>
-              <a:rPr sz="1800" b="1">
-                <a:solidFill>
-                  <a:srgbClr val="1B2A4A"/>
-                </a:solidFill>
-              </a:rPr>
-              <a:t>•  No weapons, ever. </a:t>
-            </a:r>
-            <a:r>
-              <a:rPr sz="1800" b="0">
-                <a:solidFill>
-                  <a:srgbClr val="1B2A4A"/>
-                </a:solidFill>
-              </a:rPr>
-              <a:t>No fakes (signed IDs). No poisoning (scanned out).</a:t>
+              <a:defRPr sz="2400" b="1">
+                <a:solidFill>
+                  <a:srgbClr val="F8FAFC"/>
+                </a:solidFill>
+              </a:defRPr>
+            </a:pPr>
+            <a:r>
+              <a:t>Unified Cross-Platform Zero-Touch Launchers</a:t>
+            </a:r>
+          </a:p>
+        </p:txBody>
+      </p:sp>
+      <p:sp>
+        <p:nvSpPr>
+          <p:cNvPr id="4" name="Rounded Rectangle 3"/>
+          <p:cNvSpPr/>
+          <p:nvPr/>
+        </p:nvSpPr>
+        <p:spPr>
+          <a:xfrm>
+            <a:off x="731520" y="1645920"/>
+            <a:ext cx="3291840" cy="4572000"/>
+          </a:xfrm>
+          <a:prstGeom prst="roundRect">
+            <a:avLst/>
+          </a:prstGeom>
+          <a:solidFill>
+            <a:srgbClr val="172132"/>
+          </a:solidFill>
+          <a:ln w="12700">
+            <a:solidFill>
+              <a:srgbClr val="334155"/>
+            </a:solidFill>
+          </a:ln>
+        </p:spPr>
+        <p:style>
+          <a:lnRef idx="1">
+            <a:schemeClr val="accent1"/>
+          </a:lnRef>
+          <a:fillRef idx="3">
+            <a:schemeClr val="accent1"/>
+          </a:fillRef>
+          <a:effectRef idx="2">
+            <a:schemeClr val="accent1"/>
+          </a:effectRef>
+          <a:fontRef idx="minor">
+            <a:schemeClr val="lt1"/>
+          </a:fontRef>
+        </p:style>
+        <p:txBody>
+          <a:bodyPr rtlCol="0" anchor="ctr" wrap="square" lIns="228600" rIns="228600" tIns="201168" bIns="201168"/>
+          <a:lstStyle/>
+          <a:p>
+            <a:pPr algn="ctr">
+              <a:defRPr sz="1400" b="1">
+                <a:solidFill>
+                  <a:srgbClr val="38BDF8"/>
+                </a:solidFill>
+              </a:defRPr>
+            </a:pPr>
+            <a:r>
+              <a:t>🐧 Linux &amp; macOS</a:t>
             </a:r>
           </a:p>
           <a:p>
             <a:pPr>
               <a:spcBef>
-                <a:spcPts val="400"/>
+                <a:spcPts val="800"/>
               </a:spcBef>
-              <a:spcAft>
-                <a:spcPts val="1000"/>
-              </a:spcAft>
-            </a:pPr>
-            <a:r>
-              <a:rPr sz="1800" b="1">
-                <a:solidFill>
-                  <a:srgbClr val="1B2A4A"/>
-                </a:solidFill>
-              </a:rPr>
-              <a:t>•  Scammers blocked at the door; </a:t>
-            </a:r>
-            <a:r>
-              <a:rPr sz="1800" b="0">
-                <a:solidFill>
-                  <a:srgbClr val="1B2A4A"/>
-                </a:solidFill>
-              </a:rPr>
-              <a:t>abusive operators lose their cash bond.</a:t>
+              <a:defRPr sz="1100">
+                <a:solidFill>
+                  <a:srgbClr val="94A3B8"/>
+                </a:solidFill>
+              </a:defRPr>
+            </a:pPr>
+            <a:r>
+              <a:t>• Unified ./start.sh:</a:t>
+            </a:r>
+            <a:br/>
+            <a:r>
+              <a:t>  Detects Python 3.10+, bootstraps isolated ./venv, installs dependencies, generates .env credentials, and launches node.</a:t>
+            </a:r>
+            <a:br/>
+            <a:r>
+              <a:t>• Flags Supported:</a:t>
+            </a:r>
+            <a:br/>
+            <a:r>
+              <a:t>  --install-only, --build, --version.</a:t>
+            </a:r>
+            <a:br/>
+            <a:r>
+              <a:t>• Headless Daemon: Full systemd &amp; Docker container support.</a:t>
+            </a:r>
+          </a:p>
+        </p:txBody>
+      </p:sp>
+      <p:sp>
+        <p:nvSpPr>
+          <p:cNvPr id="5" name="Rounded Rectangle 4"/>
+          <p:cNvSpPr/>
+          <p:nvPr/>
+        </p:nvSpPr>
+        <p:spPr>
+          <a:xfrm>
+            <a:off x="4389120" y="1645920"/>
+            <a:ext cx="3291840" cy="4572000"/>
+          </a:xfrm>
+          <a:prstGeom prst="roundRect">
+            <a:avLst/>
+          </a:prstGeom>
+          <a:solidFill>
+            <a:srgbClr val="172132"/>
+          </a:solidFill>
+          <a:ln w="12700">
+            <a:solidFill>
+              <a:srgbClr val="334155"/>
+            </a:solidFill>
+          </a:ln>
+        </p:spPr>
+        <p:style>
+          <a:lnRef idx="1">
+            <a:schemeClr val="accent1"/>
+          </a:lnRef>
+          <a:fillRef idx="3">
+            <a:schemeClr val="accent1"/>
+          </a:fillRef>
+          <a:effectRef idx="2">
+            <a:schemeClr val="accent1"/>
+          </a:effectRef>
+          <a:fontRef idx="minor">
+            <a:schemeClr val="lt1"/>
+          </a:fontRef>
+        </p:style>
+        <p:txBody>
+          <a:bodyPr rtlCol="0" anchor="ctr" wrap="square" lIns="228600" rIns="228600" tIns="201168" bIns="201168"/>
+          <a:lstStyle/>
+          <a:p>
+            <a:pPr algn="ctr">
+              <a:defRPr sz="1400" b="1">
+                <a:solidFill>
+                  <a:srgbClr val="34D399"/>
+                </a:solidFill>
+              </a:defRPr>
+            </a:pPr>
+            <a:r>
+              <a:t>🪟 Windows Batch &amp; PowerShell</a:t>
             </a:r>
           </a:p>
           <a:p>
             <a:pPr>
               <a:spcBef>
-                <a:spcPts val="400"/>
+                <a:spcPts val="800"/>
               </a:spcBef>
-              <a:spcAft>
-                <a:spcPts val="1000"/>
-              </a:spcAft>
-            </a:pPr>
-            <a:r>
-              <a:rPr sz="1800" b="1">
-                <a:solidFill>
-                  <a:srgbClr val="1B2A4A"/>
-                </a:solidFill>
-              </a:rPr>
-              <a:t>•  Community court + human-supervised juries </a:t>
-            </a:r>
-            <a:r>
-              <a:rPr sz="1800" b="0">
-                <a:solidFill>
-                  <a:srgbClr val="1B2A4A"/>
-                </a:solidFill>
-              </a:rPr>
-              <a:t>for anything flagged.</a:t>
+              <a:defRPr sz="1100">
+                <a:solidFill>
+                  <a:srgbClr val="94A3B8"/>
+                </a:solidFill>
+              </a:defRPr>
+            </a:pPr>
+            <a:r>
+              <a:t>• Double-Click start.bat:</a:t>
+            </a:r>
+            <a:br/>
+            <a:r>
+              <a:t>  Instant launch from Windows File Explorer with automatic Python / py discovery.</a:t>
+            </a:r>
+            <a:br/>
+            <a:r>
+              <a:t>• Modern start.ps1:</a:t>
+            </a:r>
+            <a:br/>
+            <a:r>
+              <a:t>  Full PowerShell 5.1/7+ script with colored telemetry and modular parameter switches.</a:t>
+            </a:r>
+            <a:br/>
+            <a:r>
+              <a:t>• Portable Relative Paths: Zero hardcoded directories.</a:t>
+            </a:r>
+          </a:p>
+        </p:txBody>
+      </p:sp>
+      <p:sp>
+        <p:nvSpPr>
+          <p:cNvPr id="6" name="Rounded Rectangle 5"/>
+          <p:cNvSpPr/>
+          <p:nvPr/>
+        </p:nvSpPr>
+        <p:spPr>
+          <a:xfrm>
+            <a:off x="8046720" y="1645920"/>
+            <a:ext cx="3383280" cy="4572000"/>
+          </a:xfrm>
+          <a:prstGeom prst="roundRect">
+            <a:avLst/>
+          </a:prstGeom>
+          <a:solidFill>
+            <a:srgbClr val="172132"/>
+          </a:solidFill>
+          <a:ln w="12700">
+            <a:solidFill>
+              <a:srgbClr val="334155"/>
+            </a:solidFill>
+          </a:ln>
+        </p:spPr>
+        <p:style>
+          <a:lnRef idx="1">
+            <a:schemeClr val="accent1"/>
+          </a:lnRef>
+          <a:fillRef idx="3">
+            <a:schemeClr val="accent1"/>
+          </a:fillRef>
+          <a:effectRef idx="2">
+            <a:schemeClr val="accent1"/>
+          </a:effectRef>
+          <a:fontRef idx="minor">
+            <a:schemeClr val="lt1"/>
+          </a:fontRef>
+        </p:style>
+        <p:txBody>
+          <a:bodyPr rtlCol="0" anchor="ctr" wrap="square" lIns="228600" rIns="228600" tIns="201168" bIns="201168"/>
+          <a:lstStyle/>
+          <a:p>
+            <a:pPr algn="ctr">
+              <a:defRPr sz="1400" b="1">
+                <a:solidFill>
+                  <a:srgbClr val="A855F7"/>
+                </a:solidFill>
+              </a:defRPr>
+            </a:pPr>
+            <a:r>
+              <a:t>⚙️ Automated CI/CD &amp; Tests</a:t>
+            </a:r>
+          </a:p>
+          <a:p>
+            <a:pPr>
+              <a:spcBef>
+                <a:spcPts val="800"/>
+              </a:spcBef>
+              <a:defRPr sz="1100">
+                <a:solidFill>
+                  <a:srgbClr val="94A3B8"/>
+                </a:solidFill>
+              </a:defRPr>
+            </a:pPr>
+            <a:r>
+              <a:t>• 72 Unit Tests Passing:</a:t>
+            </a:r>
+            <a:br/>
+            <a:r>
+              <a:t>  Covers democratic sharding, DEX AMM math, Hive shield, forensic signatures, and gauntlet loops.</a:t>
+            </a:r>
+            <a:br/>
+            <a:r>
+              <a:t>• GitHub Actions Matrix:</a:t>
+            </a:r>
+            <a:br/>
+            <a:r>
+              <a:t>  Continuous integration testing on both ubuntu-latest and windows-latest across Python 3.11 &amp; 3.12.</a:t>
             </a:r>
           </a:p>
         </p:txBody>
@@ -4859,14 +6174,6 @@
 <file path=ppt/slides/slide9.xml><?xml version="1.0" encoding="utf-8"?>
 <p:sld xmlns:a="http://schemas.openxmlformats.org/drawingml/2006/main" xmlns:p="http://schemas.openxmlformats.org/presentationml/2006/main" xmlns:r="http://schemas.openxmlformats.org/officeDocument/2006/relationships">
   <p:cSld>
-    <p:bg>
-      <p:bgPr>
-        <a:solidFill>
-          <a:srgbClr val="F5F7FA"/>
-        </a:solidFill>
-        <a:effectLst/>
-      </p:bgPr>
-    </p:bg>
     <p:spTree>
       <p:nvGrpSpPr>
         <p:cNvPr id="1" name=""/>
@@ -4883,13 +6190,13 @@
         <p:spPr>
           <a:xfrm>
             <a:off x="0" y="0"/>
-            <a:ext cx="12191695" cy="73152"/>
+            <a:ext cx="12191695" cy="6858000"/>
           </a:xfrm>
           <a:prstGeom prst="rect">
             <a:avLst/>
           </a:prstGeom>
           <a:solidFill>
-            <a:srgbClr val="0E7C6B"/>
+            <a:srgbClr val="0F172A"/>
           </a:solidFill>
           <a:ln>
             <a:noFill/>
@@ -4925,8 +6232,8 @@
         </p:nvSpPr>
         <p:spPr>
           <a:xfrm>
-            <a:off x="640080" y="320040"/>
-            <a:ext cx="10881360" cy="822960"/>
+            <a:off x="731520" y="457200"/>
+            <a:ext cx="10728655" cy="1005840"/>
           </a:xfrm>
           <a:prstGeom prst="rect">
             <a:avLst/>
@@ -4934,145 +6241,311 @@
           <a:noFill/>
         </p:spPr>
         <p:txBody>
-          <a:bodyPr wrap="none">
+          <a:bodyPr wrap="square">
             <a:spAutoFit/>
           </a:bodyPr>
           <a:lstStyle/>
           <a:p>
-            <a:r>
-              <a:rPr sz="3000" b="1">
-                <a:solidFill>
-                  <a:srgbClr val="1B2A4A"/>
-                </a:solidFill>
-              </a:rPr>
-              <a:t>Growth flywheel</a:t>
-            </a:r>
-          </a:p>
-        </p:txBody>
-      </p:sp>
-      <p:sp>
-        <p:nvSpPr>
-          <p:cNvPr id="4" name="TextBox 3"/>
-          <p:cNvSpPr txBox="1"/>
-          <p:nvPr/>
-        </p:nvSpPr>
-        <p:spPr>
-          <a:xfrm>
-            <a:off x="822960" y="1371600"/>
-            <a:ext cx="10515600" cy="5029200"/>
-          </a:xfrm>
-          <a:prstGeom prst="rect">
-            <a:avLst/>
-          </a:prstGeom>
-          <a:noFill/>
-        </p:spPr>
-        <p:txBody>
-          <a:bodyPr wrap="none">
-            <a:spAutoFit/>
-          </a:bodyPr>
-          <a:lstStyle/>
+            <a:pPr>
+              <a:defRPr sz="1000" b="1">
+                <a:solidFill>
+                  <a:srgbClr val="38BDF8"/>
+                </a:solidFill>
+              </a:defRPr>
+            </a:pPr>
+            <a:r>
+              <a:t>DEFENSIBILITY, MOAT &amp; STRATEGIC POSITIONING</a:t>
+            </a:r>
+          </a:p>
           <a:p>
             <a:pPr>
               <a:spcBef>
                 <a:spcPts val="400"/>
               </a:spcBef>
-              <a:spcAft>
-                <a:spcPts val="1000"/>
-              </a:spcAft>
-            </a:pPr>
-            <a:r>
-              <a:rPr sz="1800" b="1">
-                <a:solidFill>
-                  <a:srgbClr val="1B2A4A"/>
-                </a:solidFill>
-              </a:rPr>
-              <a:t>•  Free debates → </a:t>
-            </a:r>
-            <a:r>
-              <a:rPr sz="1800" b="0">
-                <a:solidFill>
-                  <a:srgbClr val="1B2A4A"/>
-                </a:solidFill>
-              </a:rPr>
-              <a:t>friends invited (bounty) → more hosts (pay) → smarter free models → more debates.</a:t>
+              <a:defRPr sz="2400" b="1">
+                <a:solidFill>
+                  <a:srgbClr val="F8FAFC"/>
+                </a:solidFill>
+              </a:defRPr>
+            </a:pPr>
+            <a:r>
+              <a:t>Competitive Advantages: Why Shill Wins</a:t>
+            </a:r>
+          </a:p>
+        </p:txBody>
+      </p:sp>
+      <p:sp>
+        <p:nvSpPr>
+          <p:cNvPr id="4" name="Rounded Rectangle 3"/>
+          <p:cNvSpPr/>
+          <p:nvPr/>
+        </p:nvSpPr>
+        <p:spPr>
+          <a:xfrm>
+            <a:off x="731520" y="1645920"/>
+            <a:ext cx="5303520" cy="2194560"/>
+          </a:xfrm>
+          <a:prstGeom prst="roundRect">
+            <a:avLst/>
+          </a:prstGeom>
+          <a:solidFill>
+            <a:srgbClr val="172132"/>
+          </a:solidFill>
+          <a:ln w="12700">
+            <a:solidFill>
+              <a:srgbClr val="334155"/>
+            </a:solidFill>
+          </a:ln>
+        </p:spPr>
+        <p:style>
+          <a:lnRef idx="1">
+            <a:schemeClr val="accent1"/>
+          </a:lnRef>
+          <a:fillRef idx="3">
+            <a:schemeClr val="accent1"/>
+          </a:fillRef>
+          <a:effectRef idx="2">
+            <a:schemeClr val="accent1"/>
+          </a:effectRef>
+          <a:fontRef idx="minor">
+            <a:schemeClr val="lt1"/>
+          </a:fontRef>
+        </p:style>
+        <p:txBody>
+          <a:bodyPr rtlCol="0" anchor="ctr" wrap="square" lIns="228600" rIns="228600" tIns="201168" bIns="201168"/>
+          <a:lstStyle/>
+          <a:p>
+            <a:pPr algn="ctr">
+              <a:defRPr sz="1400" b="1">
+                <a:solidFill>
+                  <a:srgbClr val="38BDF8"/>
+                </a:solidFill>
+              </a:defRPr>
+            </a:pPr>
+            <a:r>
+              <a:t>1. Self-Verifying Data Flywheel</a:t>
             </a:r>
           </a:p>
           <a:p>
             <a:pPr>
               <a:spcBef>
-                <a:spcPts val="400"/>
+                <a:spcPts val="800"/>
               </a:spcBef>
-              <a:spcAft>
-                <a:spcPts val="1000"/>
-              </a:spcAft>
-            </a:pPr>
-            <a:r>
-              <a:rPr sz="1800" b="1">
-                <a:solidFill>
-                  <a:srgbClr val="1B2A4A"/>
-                </a:solidFill>
-              </a:rPr>
-              <a:t>•  Phase 1: </a:t>
-            </a:r>
-            <a:r>
-              <a:rPr sz="1800" b="0">
-                <a:solidFill>
-                  <a:srgbClr val="1B2A4A"/>
-                </a:solidFill>
-              </a:rPr>
-              <a:t>campuses — 1,000 weekly debaters.</a:t>
+              <a:defRPr sz="1100">
+                <a:solidFill>
+                  <a:srgbClr val="94A3B8"/>
+                </a:solidFill>
+              </a:defRPr>
+            </a:pPr>
+            <a:r>
+              <a:t>Competitors train on uncurated web data. Shill continuously generates proprietary high-density, multi-perspective dialectic dialogues that are mathematically scored, deduplicated, and packaged into golden datasets.</a:t>
+            </a:r>
+          </a:p>
+        </p:txBody>
+      </p:sp>
+      <p:sp>
+        <p:nvSpPr>
+          <p:cNvPr id="5" name="Rounded Rectangle 4"/>
+          <p:cNvSpPr/>
+          <p:nvPr/>
+        </p:nvSpPr>
+        <p:spPr>
+          <a:xfrm>
+            <a:off x="731520" y="4114800"/>
+            <a:ext cx="5303520" cy="2194560"/>
+          </a:xfrm>
+          <a:prstGeom prst="roundRect">
+            <a:avLst/>
+          </a:prstGeom>
+          <a:solidFill>
+            <a:srgbClr val="172132"/>
+          </a:solidFill>
+          <a:ln w="12700">
+            <a:solidFill>
+              <a:srgbClr val="334155"/>
+            </a:solidFill>
+          </a:ln>
+        </p:spPr>
+        <p:style>
+          <a:lnRef idx="1">
+            <a:schemeClr val="accent1"/>
+          </a:lnRef>
+          <a:fillRef idx="3">
+            <a:schemeClr val="accent1"/>
+          </a:fillRef>
+          <a:effectRef idx="2">
+            <a:schemeClr val="accent1"/>
+          </a:effectRef>
+          <a:fontRef idx="minor">
+            <a:schemeClr val="lt1"/>
+          </a:fontRef>
+        </p:style>
+        <p:txBody>
+          <a:bodyPr rtlCol="0" anchor="ctr" wrap="square" lIns="228600" rIns="228600" tIns="201168" bIns="201168"/>
+          <a:lstStyle/>
+          <a:p>
+            <a:pPr algn="ctr">
+              <a:defRPr sz="1400" b="1">
+                <a:solidFill>
+                  <a:srgbClr val="34D399"/>
+                </a:solidFill>
+              </a:defRPr>
+            </a:pPr>
+            <a:r>
+              <a:t>2. Extreme Democratization &amp; Community Goodwill</a:t>
             </a:r>
           </a:p>
           <a:p>
             <a:pPr>
               <a:spcBef>
-                <a:spcPts val="400"/>
+                <a:spcPts val="800"/>
               </a:spcBef>
-              <a:spcAft>
-                <a:spcPts val="1000"/>
-              </a:spcAft>
-            </a:pPr>
-            <a:r>
-              <a:rPr sz="1800" b="1">
-                <a:solidFill>
-                  <a:srgbClr val="1B2A4A"/>
-                </a:solidFill>
-              </a:rPr>
-              <a:t>•  Phase 2-3: </a:t>
-            </a:r>
-            <a:r>
-              <a:rPr sz="1800" b="0">
-                <a:solidFill>
-                  <a:srgbClr val="1B2A4A"/>
-                </a:solidFill>
-              </a:rPr>
-              <a:t>builders + anchor communities — API keys, own rooms.</a:t>
+              <a:defRPr sz="1100">
+                <a:solidFill>
+                  <a:srgbClr val="94A3B8"/>
+                </a:solidFill>
+              </a:defRPr>
+            </a:pPr>
+            <a:r>
+              <a:t>By offering 100 free queries/day and a tiny &lt;64MB volunteer node footprint, Shill builds rapid grassroots adoption that closed corporate AI providers cannot match.</a:t>
+            </a:r>
+          </a:p>
+        </p:txBody>
+      </p:sp>
+      <p:sp>
+        <p:nvSpPr>
+          <p:cNvPr id="6" name="Rounded Rectangle 5"/>
+          <p:cNvSpPr/>
+          <p:nvPr/>
+        </p:nvSpPr>
+        <p:spPr>
+          <a:xfrm>
+            <a:off x="6309360" y="1645920"/>
+            <a:ext cx="5120640" cy="2194560"/>
+          </a:xfrm>
+          <a:prstGeom prst="roundRect">
+            <a:avLst/>
+          </a:prstGeom>
+          <a:solidFill>
+            <a:srgbClr val="172132"/>
+          </a:solidFill>
+          <a:ln w="12700">
+            <a:solidFill>
+              <a:srgbClr val="334155"/>
+            </a:solidFill>
+          </a:ln>
+        </p:spPr>
+        <p:style>
+          <a:lnRef idx="1">
+            <a:schemeClr val="accent1"/>
+          </a:lnRef>
+          <a:fillRef idx="3">
+            <a:schemeClr val="accent1"/>
+          </a:fillRef>
+          <a:effectRef idx="2">
+            <a:schemeClr val="accent1"/>
+          </a:effectRef>
+          <a:fontRef idx="minor">
+            <a:schemeClr val="lt1"/>
+          </a:fontRef>
+        </p:style>
+        <p:txBody>
+          <a:bodyPr rtlCol="0" anchor="ctr" wrap="square" lIns="228600" rIns="228600" tIns="201168" bIns="201168"/>
+          <a:lstStyle/>
+          <a:p>
+            <a:pPr algn="ctr">
+              <a:defRPr sz="1400" b="1">
+                <a:solidFill>
+                  <a:srgbClr val="F59E0B"/>
+                </a:solidFill>
+              </a:defRPr>
+            </a:pPr>
+            <a:r>
+              <a:t>3. Forensic Proof of Generation</a:t>
             </a:r>
           </a:p>
           <a:p>
             <a:pPr>
               <a:spcBef>
-                <a:spcPts val="400"/>
+                <a:spcPts val="800"/>
               </a:spcBef>
-              <a:spcAft>
-                <a:spcPts val="1000"/>
-              </a:spcAft>
-            </a:pPr>
-            <a:r>
-              <a:rPr sz="1800" b="1">
-                <a:solidFill>
-                  <a:srgbClr val="1B2A4A"/>
-                </a:solidFill>
-              </a:rPr>
-              <a:t>•  12-month pledge: </a:t>
-            </a:r>
-            <a:r>
-              <a:rPr sz="1800" b="0">
-                <a:solidFill>
-                  <a:srgbClr val="1B2A4A"/>
-                </a:solidFill>
-              </a:rPr>
-              <a:t>10K weekly debaters, 5 community models, payouts exceed costs.</a:t>
+              <a:defRPr sz="1100">
+                <a:solidFill>
+                  <a:srgbClr val="94A3B8"/>
+                </a:solidFill>
+              </a:defRPr>
+            </a:pPr>
+            <a:r>
+              <a:t>Every synthesized answer has an immutable Ed25519 cryptographic signature and verifiable on-chain badge (0x...), solving AI accountability and copyright attribution for enterprise clients.</a:t>
+            </a:r>
+          </a:p>
+        </p:txBody>
+      </p:sp>
+      <p:sp>
+        <p:nvSpPr>
+          <p:cNvPr id="7" name="Rounded Rectangle 6"/>
+          <p:cNvSpPr/>
+          <p:nvPr/>
+        </p:nvSpPr>
+        <p:spPr>
+          <a:xfrm>
+            <a:off x="6309360" y="4114800"/>
+            <a:ext cx="5120640" cy="2194560"/>
+          </a:xfrm>
+          <a:prstGeom prst="roundRect">
+            <a:avLst/>
+          </a:prstGeom>
+          <a:solidFill>
+            <a:srgbClr val="172132"/>
+          </a:solidFill>
+          <a:ln w="12700">
+            <a:solidFill>
+              <a:srgbClr val="334155"/>
+            </a:solidFill>
+          </a:ln>
+        </p:spPr>
+        <p:style>
+          <a:lnRef idx="1">
+            <a:schemeClr val="accent1"/>
+          </a:lnRef>
+          <a:fillRef idx="3">
+            <a:schemeClr val="accent1"/>
+          </a:fillRef>
+          <a:effectRef idx="2">
+            <a:schemeClr val="accent1"/>
+          </a:effectRef>
+          <a:fontRef idx="minor">
+            <a:schemeClr val="lt1"/>
+          </a:fontRef>
+        </p:style>
+        <p:txBody>
+          <a:bodyPr rtlCol="0" anchor="ctr" wrap="square" lIns="228600" rIns="228600" tIns="201168" bIns="201168"/>
+          <a:lstStyle/>
+          <a:p>
+            <a:pPr algn="ctr">
+              <a:defRPr sz="1400" b="1">
+                <a:solidFill>
+                  <a:srgbClr val="A855F7"/>
+                </a:solidFill>
+              </a:defRPr>
+            </a:pPr>
+            <a:r>
+              <a:t>4. Zero-Friction Dual Licensing</a:t>
+            </a:r>
+          </a:p>
+          <a:p>
+            <a:pPr>
+              <a:spcBef>
+                <a:spcPts val="800"/>
+              </a:spcBef>
+              <a:defRPr sz="1100">
+                <a:solidFill>
+                  <a:srgbClr val="94A3B8"/>
+                </a:solidFill>
+              </a:defRPr>
+            </a:pPr>
+            <a:r>
+              <a:t>Permissive Apache 2.0 open-source adoption drives viral developer uptake, while enterprise compliance requirements naturally funnel commercial clients into high-margin OEM licenses.</a:t>
             </a:r>
           </a:p>
         </p:txBody>

</xml_diff>